<commit_message>
Decks: screenshots of the restyled dashboard
</commit_message>
<xml_diff>
--- a/docs/Goflix-presentasi.pptx
+++ b/docs/Goflix-presentasi.pptx
@@ -121,25 +121,25 @@
   <p:extLst>
     <p:ext uri="{521415D9-36F7-43E2-AB2F-B90AF26B5E84}">
       <p14:sectionLst xmlns:p14="http://schemas.microsoft.com/office/powerpoint/2010/main">
-        <p14:section name="Pembuka" id="{9a21b18b-8169-a086-8a53-ca3f0301aecc}">
+        <p14:section name="Pembuka" id="{a652c4d5-4a4a-f64b-ee93-3294f07b7679}">
           <p14:sldIdLst>
             <p14:sldId id="256"/>
           </p14:sldIdLst>
         </p14:section>
-        <p14:section name="Produk" id="{5aee3eee-bbf8-3b87-532f-0092ef907bc8}">
+        <p14:section name="Produk" id="{6e25a1dc-a541-f8bf-8f24-015ff25aa4ac}">
           <p14:sldIdLst>
             <p14:sldId id="257"/>
             <p14:sldId id="258"/>
           </p14:sldIdLst>
         </p14:section>
-        <p14:section name="Desain sistem" id="{e29724dc-af3c-0286-116f-8a9d0edc51bc}">
+        <p14:section name="Desain sistem" id="{191ef0a7-d827-75e9-c5a9-d246db1685aa}">
           <p14:sldIdLst>
             <p14:sldId id="259"/>
             <p14:sldId id="260"/>
             <p14:sldId id="261"/>
           </p14:sldIdLst>
         </p14:section>
-        <p14:section name="Aturan bisnis" id="{7b2fe5df-cdef-0faa-28c9-9284dc927eed}">
+        <p14:section name="Aturan bisnis" id="{800dba55-9687-91ce-aa14-48b2b7feef58}">
           <p14:sldIdLst>
             <p14:sldId id="262"/>
             <p14:sldId id="263"/>
@@ -147,14 +147,14 @@
             <p14:sldId id="265"/>
           </p14:sldIdLst>
         </p14:section>
-        <p14:section name="Kode" id="{deb52c0d-0b8e-e1aa-c5d8-c6153332a833}">
+        <p14:section name="Kode" id="{e1e529da-cdf9-b09e-0c42-947900e101b0}">
           <p14:sldIdLst>
             <p14:sldId id="266"/>
             <p14:sldId id="267"/>
             <p14:sldId id="268"/>
           </p14:sldIdLst>
         </p14:section>
-        <p14:section name="Penutup" id="{be00b0d7-c982-0aeb-4c7c-43fcfbbe50eb}">
+        <p14:section name="Penutup" id="{42c3c3e2-6d0f-a137-b893-b71cb6326369}">
           <p14:sldIdLst>
             <p14:sldId id="269"/>
             <p14:sldId id="270"/>
@@ -3916,7 +3916,7 @@
                   <a:schemeClr val="accent4"/>
                 </a:solidFill>
               </a:rPr>
-              <a:t>Demo: Laravel 10, Blade, Tailwind, Chart.js, dan PostgreSQL seperti produksi. Hijau dan hitam adalah bagian yang saya kerjakan.</a:t>
+              <a:t>Demo: Laravel 10, Blade, Tailwind, Chart.js, dan PostgreSQL seperti produksi. Yang hijau adalah bagian saya.</a:t>
             </a:r>
             <a:endParaRPr lang="en-US" sz="1500" dirty="0"/>
           </a:p>
@@ -4078,11 +4078,11 @@
         <p:spPr>
           <a:xfrm>
             <a:off x="548640" y="1600200"/>
-            <a:ext cx="6949440" cy="4526280"/>
+            <a:ext cx="6949440" cy="3931920"/>
           </a:xfrm>
           <a:prstGeom prst="roundRect">
             <a:avLst>
-              <a:gd name="adj" fmla="val 2424"/>
+              <a:gd name="adj" fmla="val 2791"/>
             </a:avLst>
           </a:prstGeom>
           <a:solidFill>

</xml_diff>

<commit_message>
Decks: tables for trade-offs, stack and open work; plainer titles
</commit_message>
<xml_diff>
--- a/docs/Goflix-presentasi.pptx
+++ b/docs/Goflix-presentasi.pptx
@@ -121,25 +121,25 @@
   <p:extLst>
     <p:ext uri="{521415D9-36F7-43E2-AB2F-B90AF26B5E84}">
       <p14:sectionLst xmlns:p14="http://schemas.microsoft.com/office/powerpoint/2010/main">
-        <p14:section name="Pembuka" id="{a652c4d5-4a4a-f64b-ee93-3294f07b7679}">
+        <p14:section name="Pembuka" id="{5ad140c1-490e-e761-18a6-5408947110eb}">
           <p14:sldIdLst>
             <p14:sldId id="256"/>
           </p14:sldIdLst>
         </p14:section>
-        <p14:section name="Produk" id="{6e25a1dc-a541-f8bf-8f24-015ff25aa4ac}">
+        <p14:section name="Produk" id="{3494c66b-83a1-8934-8db7-b773023c0b9e}">
           <p14:sldIdLst>
             <p14:sldId id="257"/>
             <p14:sldId id="258"/>
           </p14:sldIdLst>
         </p14:section>
-        <p14:section name="Desain sistem" id="{191ef0a7-d827-75e9-c5a9-d246db1685aa}">
+        <p14:section name="Desain sistem" id="{7683d168-5db7-9467-d6c1-51e32a9cfc4c}">
           <p14:sldIdLst>
             <p14:sldId id="259"/>
             <p14:sldId id="260"/>
             <p14:sldId id="261"/>
           </p14:sldIdLst>
         </p14:section>
-        <p14:section name="Aturan bisnis" id="{800dba55-9687-91ce-aa14-48b2b7feef58}">
+        <p14:section name="Aturan bisnis" id="{5c72ec1a-b064-818a-d84c-1a856e2ee4f1}">
           <p14:sldIdLst>
             <p14:sldId id="262"/>
             <p14:sldId id="263"/>
@@ -147,14 +147,14 @@
             <p14:sldId id="265"/>
           </p14:sldIdLst>
         </p14:section>
-        <p14:section name="Kode" id="{e1e529da-cdf9-b09e-0c42-947900e101b0}">
+        <p14:section name="Kode" id="{013de41e-a481-b0db-384c-c2bf6ea8627c}">
           <p14:sldIdLst>
             <p14:sldId id="266"/>
             <p14:sldId id="267"/>
             <p14:sldId id="268"/>
           </p14:sldIdLst>
         </p14:section>
-        <p14:section name="Penutup" id="{42c3c3e2-6d0f-a137-b893-b71cb6326369}">
+        <p14:section name="Penutup" id="{5c216958-66d1-7a55-2149-922c0ceae678}">
           <p14:sldIdLst>
             <p14:sldId id="269"/>
             <p14:sldId id="270"/>
@@ -652,7 +652,7 @@
           <a:p>
             <a:r>
               <a:rPr lang="en-US" dirty="0"/>
-              <a:t>Siapkan alasan dan risiko masing-masing. Contoh: data ganda di users berisiko tidak sinkron, jadi hanya satu service yang boleh mengubahnya.</a:t>
+              <a:t>Untuk setiap keputusan, sebutkan juga harganya. Pewawancara biasanya paling tertarik pada kolom terakhir.</a:t>
             </a:r>
             <a:endParaRPr lang="en-US" dirty="0"/>
           </a:p>
@@ -740,7 +740,7 @@
           <a:p>
             <a:r>
               <a:rPr lang="en-US" dirty="0"/>
-              <a:t>Demo juga memakai Blade, Tailwind, dan Chart.js, dan berjalan di PostgreSQL seperti produksi.</a:t>
+              <a:t>Kolom alternatif menunjukkan bahwa pilihannya disengaja. Siapkan satu contoh untuk tiap baris.</a:t>
             </a:r>
             <a:endParaRPr lang="en-US" dirty="0"/>
           </a:p>
@@ -1004,7 +1004,7 @@
           <a:p>
             <a:r>
               <a:rPr lang="en-US" dirty="0"/>
-              <a:t>Pilih satu atau dua yang paling siap dibahas.</a:t>
+              <a:t>Menyebutkan yang belum selesai sendiri menunjukkan saya tahu di mana sistemnya tipis. Pilih satu untuk dibahas.</a:t>
             </a:r>
             <a:endParaRPr lang="en-US" dirty="0"/>
           </a:p>
@@ -2761,576 +2761,932 @@
                   <a:schemeClr val="tx1"/>
                 </a:solidFill>
               </a:rPr>
-              <a:t>Keputusan yang layak dibahas</a:t>
+              <a:t>Trade-off yang saya pilih</a:t>
             </a:r>
             <a:endParaRPr lang="en-US" sz="3200" dirty="0"/>
           </a:p>
         </p:txBody>
       </p:sp>
-      <p:sp>
-        <p:nvSpPr>
-          <p:cNvPr id="5" name="card"/>
-          <p:cNvSpPr/>
-          <p:nvPr/>
-        </p:nvSpPr>
-        <p:spPr>
-          <a:xfrm>
-            <a:off x="548640" y="1691640"/>
-            <a:ext cx="5440680" cy="1920240"/>
-          </a:xfrm>
-          <a:prstGeom prst="roundRect">
-            <a:avLst>
-              <a:gd name="adj" fmla="val 5714"/>
-            </a:avLst>
-          </a:prstGeom>
-          <a:solidFill>
-            <a:schemeClr val="bg2"/>
-          </a:solidFill>
-          <a:ln w="12700">
-            <a:solidFill>
-              <a:schemeClr val="bg2"/>
-            </a:solidFill>
-            <a:prstDash val="solid"/>
-          </a:ln>
-        </p:spPr>
-      </p:sp>
-      <p:sp>
-        <p:nvSpPr>
-          <p:cNvPr id="6" name="Text 3"/>
-          <p:cNvSpPr txBox="1"/>
-          <p:nvPr/>
-        </p:nvSpPr>
-        <p:spPr>
-          <a:xfrm>
-            <a:off x="822960" y="1920240"/>
-            <a:ext cx="548640" cy="640080"/>
-          </a:xfrm>
-          <a:prstGeom prst="rect">
-            <a:avLst/>
-          </a:prstGeom>
-          <a:noFill/>
-          <a:ln/>
-        </p:spPr>
-        <p:txBody>
-          <a:bodyPr wrap="square" lIns="0" tIns="0" rIns="0" bIns="0" rtlCol="0" anchor="ctr"/>
-          <a:lstStyle/>
-          <a:p>
-            <a:pPr indent="0" marL="0">
-              <a:buNone/>
-            </a:pPr>
-            <a:r>
-              <a:rPr lang="en-US" sz="3000" b="1" dirty="0">
-                <a:solidFill>
-                  <a:schemeClr val="accent1"/>
-                </a:solidFill>
-                <a:latin typeface="+mj-lt" pitchFamily="34" charset="0"/>
-                <a:ea typeface="+mj-lt" pitchFamily="34" charset="-122"/>
-                <a:cs typeface="+mj-lt" pitchFamily="34" charset="-120"/>
-              </a:rPr>
-              <a:t>1</a:t>
-            </a:r>
-            <a:endParaRPr lang="en-US" sz="3000" dirty="0"/>
-          </a:p>
-        </p:txBody>
-      </p:sp>
-      <p:sp>
-        <p:nvSpPr>
-          <p:cNvPr id="7" name="Text 4"/>
-          <p:cNvSpPr txBox="1"/>
-          <p:nvPr/>
-        </p:nvSpPr>
-        <p:spPr>
-          <a:xfrm>
-            <a:off x="1463040" y="1965960"/>
-            <a:ext cx="4297680" cy="457200"/>
-          </a:xfrm>
-          <a:prstGeom prst="rect">
-            <a:avLst/>
-          </a:prstGeom>
-          <a:noFill/>
-          <a:ln/>
-        </p:spPr>
-        <p:txBody>
-          <a:bodyPr wrap="square" lIns="0" tIns="0" rIns="0" bIns="0" rtlCol="0" anchor="ctr"/>
-          <a:lstStyle/>
-          <a:p>
-            <a:pPr indent="0" marL="0">
-              <a:buNone/>
-            </a:pPr>
-            <a:r>
-              <a:rPr lang="en-US" sz="1800" b="1" dirty="0">
-                <a:solidFill>
-                  <a:schemeClr val="tx1"/>
-                </a:solidFill>
-                <a:latin typeface="+mj-lt" pitchFamily="34" charset="0"/>
-                <a:ea typeface="+mj-lt" pitchFamily="34" charset="-122"/>
-                <a:cs typeface="+mj-lt" pitchFamily="34" charset="-120"/>
-              </a:rPr>
-              <a:t>Tanggal berakhir di users</a:t>
-            </a:r>
-            <a:endParaRPr lang="en-US" sz="1800" dirty="0"/>
-          </a:p>
-        </p:txBody>
-      </p:sp>
-      <p:sp>
-        <p:nvSpPr>
-          <p:cNvPr id="8" name="Text 5"/>
-          <p:cNvSpPr txBox="1"/>
-          <p:nvPr/>
-        </p:nvSpPr>
-        <p:spPr>
-          <a:xfrm>
-            <a:off x="1463040" y="2514600"/>
-            <a:ext cx="4297680" cy="1097280"/>
-          </a:xfrm>
-          <a:prstGeom prst="rect">
-            <a:avLst/>
-          </a:prstGeom>
-          <a:noFill/>
-          <a:ln/>
-        </p:spPr>
-        <p:txBody>
-          <a:bodyPr wrap="square" lIns="0" tIns="0" rIns="0" bIns="0" rtlCol="0" anchor="t"/>
-          <a:lstStyle/>
-          <a:p>
-            <a:pPr indent="0" marL="0">
-              <a:buNone/>
-            </a:pPr>
-            <a:r>
-              <a:rPr lang="en-US" sz="1500" dirty="0">
-                <a:solidFill>
-                  <a:schemeClr val="accent4"/>
-                </a:solidFill>
-              </a:rPr>
-              <a:t>Data ganda yang disengaja: satu kolom ter-index lebih cepat untuk cek akses di setiap pemutaran.</a:t>
-            </a:r>
-            <a:endParaRPr lang="en-US" sz="1500" dirty="0"/>
-          </a:p>
-        </p:txBody>
-      </p:sp>
-      <p:sp>
-        <p:nvSpPr>
-          <p:cNvPr id="9" name="card"/>
-          <p:cNvSpPr/>
-          <p:nvPr/>
-        </p:nvSpPr>
-        <p:spPr>
-          <a:xfrm>
-            <a:off x="6172200" y="1691640"/>
-            <a:ext cx="5440680" cy="1920240"/>
-          </a:xfrm>
-          <a:prstGeom prst="roundRect">
-            <a:avLst>
-              <a:gd name="adj" fmla="val 5714"/>
-            </a:avLst>
-          </a:prstGeom>
-          <a:solidFill>
-            <a:schemeClr val="bg2"/>
-          </a:solidFill>
-          <a:ln w="12700">
-            <a:solidFill>
-              <a:schemeClr val="bg2"/>
-            </a:solidFill>
-            <a:prstDash val="solid"/>
-          </a:ln>
-        </p:spPr>
-      </p:sp>
-      <p:sp>
-        <p:nvSpPr>
-          <p:cNvPr id="10" name="Text 7"/>
-          <p:cNvSpPr txBox="1"/>
-          <p:nvPr/>
-        </p:nvSpPr>
-        <p:spPr>
-          <a:xfrm>
-            <a:off x="6446520" y="1920240"/>
-            <a:ext cx="548640" cy="640080"/>
-          </a:xfrm>
-          <a:prstGeom prst="rect">
-            <a:avLst/>
-          </a:prstGeom>
-          <a:noFill/>
-          <a:ln/>
-        </p:spPr>
-        <p:txBody>
-          <a:bodyPr wrap="square" lIns="0" tIns="0" rIns="0" bIns="0" rtlCol="0" anchor="ctr"/>
-          <a:lstStyle/>
-          <a:p>
-            <a:pPr indent="0" marL="0">
-              <a:buNone/>
-            </a:pPr>
-            <a:r>
-              <a:rPr lang="en-US" sz="3000" b="1" dirty="0">
-                <a:solidFill>
-                  <a:schemeClr val="accent1"/>
-                </a:solidFill>
-                <a:latin typeface="+mj-lt" pitchFamily="34" charset="0"/>
-                <a:ea typeface="+mj-lt" pitchFamily="34" charset="-122"/>
-                <a:cs typeface="+mj-lt" pitchFamily="34" charset="-120"/>
-              </a:rPr>
-              <a:t>2</a:t>
-            </a:r>
-            <a:endParaRPr lang="en-US" sz="3000" dirty="0"/>
-          </a:p>
-        </p:txBody>
-      </p:sp>
-      <p:sp>
-        <p:nvSpPr>
-          <p:cNvPr id="11" name="Text 8"/>
-          <p:cNvSpPr txBox="1"/>
-          <p:nvPr/>
-        </p:nvSpPr>
-        <p:spPr>
-          <a:xfrm>
-            <a:off x="7086600" y="1965960"/>
-            <a:ext cx="4297680" cy="457200"/>
-          </a:xfrm>
-          <a:prstGeom prst="rect">
-            <a:avLst/>
-          </a:prstGeom>
-          <a:noFill/>
-          <a:ln/>
-        </p:spPr>
-        <p:txBody>
-          <a:bodyPr wrap="square" lIns="0" tIns="0" rIns="0" bIns="0" rtlCol="0" anchor="ctr"/>
-          <a:lstStyle/>
-          <a:p>
-            <a:pPr indent="0" marL="0">
-              <a:buNone/>
-            </a:pPr>
-            <a:r>
-              <a:rPr lang="en-US" sz="1800" b="1" dirty="0">
-                <a:solidFill>
-                  <a:schemeClr val="tx1"/>
-                </a:solidFill>
-                <a:latin typeface="+mj-lt" pitchFamily="34" charset="0"/>
-                <a:ea typeface="+mj-lt" pitchFamily="34" charset="-122"/>
-                <a:cs typeface="+mj-lt" pitchFamily="34" charset="-120"/>
-              </a:rPr>
-              <a:t>Pembayaran tidak bisa diedit</a:t>
-            </a:r>
-            <a:endParaRPr lang="en-US" sz="1800" dirty="0"/>
-          </a:p>
-        </p:txBody>
-      </p:sp>
-      <p:sp>
-        <p:nvSpPr>
-          <p:cNvPr id="12" name="Text 9"/>
-          <p:cNvSpPr txBox="1"/>
-          <p:nvPr/>
-        </p:nvSpPr>
-        <p:spPr>
-          <a:xfrm>
-            <a:off x="7086600" y="2514600"/>
-            <a:ext cx="4297680" cy="1097280"/>
-          </a:xfrm>
-          <a:prstGeom prst="rect">
-            <a:avLst/>
-          </a:prstGeom>
-          <a:noFill/>
-          <a:ln/>
-        </p:spPr>
-        <p:txBody>
-          <a:bodyPr wrap="square" lIns="0" tIns="0" rIns="0" bIns="0" rtlCol="0" anchor="t"/>
-          <a:lstStyle/>
-          <a:p>
-            <a:pPr indent="0" marL="0">
-              <a:buNone/>
-            </a:pPr>
-            <a:r>
-              <a:rPr lang="en-US" sz="1500" dirty="0">
-                <a:solidFill>
-                  <a:schemeClr val="accent4"/>
-                </a:solidFill>
-              </a:rPr>
-              <a:t>Langganan dan sewa adalah catatan keuangan. Koreksi adalah entri baru.</a:t>
-            </a:r>
-            <a:endParaRPr lang="en-US" sz="1500" dirty="0"/>
-          </a:p>
-        </p:txBody>
-      </p:sp>
-      <p:sp>
-        <p:nvSpPr>
-          <p:cNvPr id="13" name="card"/>
-          <p:cNvSpPr/>
-          <p:nvPr/>
-        </p:nvSpPr>
-        <p:spPr>
-          <a:xfrm>
-            <a:off x="548640" y="3886200"/>
-            <a:ext cx="5440680" cy="1920240"/>
-          </a:xfrm>
-          <a:prstGeom prst="roundRect">
-            <a:avLst>
-              <a:gd name="adj" fmla="val 5714"/>
-            </a:avLst>
-          </a:prstGeom>
-          <a:solidFill>
-            <a:schemeClr val="bg2"/>
-          </a:solidFill>
-          <a:ln w="12700">
-            <a:solidFill>
-              <a:schemeClr val="bg2"/>
-            </a:solidFill>
-            <a:prstDash val="solid"/>
-          </a:ln>
-        </p:spPr>
-      </p:sp>
-      <p:sp>
-        <p:nvSpPr>
-          <p:cNvPr id="14" name="Text 11"/>
-          <p:cNvSpPr txBox="1"/>
-          <p:nvPr/>
-        </p:nvSpPr>
-        <p:spPr>
-          <a:xfrm>
-            <a:off x="822960" y="4114800"/>
-            <a:ext cx="548640" cy="640080"/>
-          </a:xfrm>
-          <a:prstGeom prst="rect">
-            <a:avLst/>
-          </a:prstGeom>
-          <a:noFill/>
-          <a:ln/>
-        </p:spPr>
-        <p:txBody>
-          <a:bodyPr wrap="square" lIns="0" tIns="0" rIns="0" bIns="0" rtlCol="0" anchor="ctr"/>
-          <a:lstStyle/>
-          <a:p>
-            <a:pPr indent="0" marL="0">
-              <a:buNone/>
-            </a:pPr>
-            <a:r>
-              <a:rPr lang="en-US" sz="3000" b="1" dirty="0">
-                <a:solidFill>
-                  <a:schemeClr val="accent1"/>
-                </a:solidFill>
-                <a:latin typeface="+mj-lt" pitchFamily="34" charset="0"/>
-                <a:ea typeface="+mj-lt" pitchFamily="34" charset="-122"/>
-                <a:cs typeface="+mj-lt" pitchFamily="34" charset="-120"/>
-              </a:rPr>
-              <a:t>3</a:t>
-            </a:r>
-            <a:endParaRPr lang="en-US" sz="3000" dirty="0"/>
-          </a:p>
-        </p:txBody>
-      </p:sp>
-      <p:sp>
-        <p:nvSpPr>
-          <p:cNvPr id="15" name="Text 12"/>
-          <p:cNvSpPr txBox="1"/>
-          <p:nvPr/>
-        </p:nvSpPr>
-        <p:spPr>
-          <a:xfrm>
-            <a:off x="1463040" y="4160520"/>
-            <a:ext cx="4297680" cy="457200"/>
-          </a:xfrm>
-          <a:prstGeom prst="rect">
-            <a:avLst/>
-          </a:prstGeom>
-          <a:noFill/>
-          <a:ln/>
-        </p:spPr>
-        <p:txBody>
-          <a:bodyPr wrap="square" lIns="0" tIns="0" rIns="0" bIns="0" rtlCol="0" anchor="ctr"/>
-          <a:lstStyle/>
-          <a:p>
-            <a:pPr indent="0" marL="0">
-              <a:buNone/>
-            </a:pPr>
-            <a:r>
-              <a:rPr lang="en-US" sz="1800" b="1" dirty="0">
-                <a:solidFill>
-                  <a:schemeClr val="tx1"/>
-                </a:solidFill>
-                <a:latin typeface="+mj-lt" pitchFamily="34" charset="0"/>
-                <a:ea typeface="+mj-lt" pitchFamily="34" charset="-122"/>
-                <a:cs typeface="+mj-lt" pitchFamily="34" charset="-120"/>
-              </a:rPr>
-              <a:t>Nonaktifkan, bukan hapus</a:t>
-            </a:r>
-            <a:endParaRPr lang="en-US" sz="1800" dirty="0"/>
-          </a:p>
-        </p:txBody>
-      </p:sp>
-      <p:sp>
-        <p:nvSpPr>
-          <p:cNvPr id="16" name="Text 13"/>
-          <p:cNvSpPr txBox="1"/>
-          <p:nvPr/>
-        </p:nvSpPr>
-        <p:spPr>
-          <a:xfrm>
-            <a:off x="1463040" y="4709160"/>
-            <a:ext cx="4297680" cy="1097280"/>
-          </a:xfrm>
-          <a:prstGeom prst="rect">
-            <a:avLst/>
-          </a:prstGeom>
-          <a:noFill/>
-          <a:ln/>
-        </p:spPr>
-        <p:txBody>
-          <a:bodyPr wrap="square" lIns="0" tIns="0" rIns="0" bIns="0" rtlCol="0" anchor="t"/>
-          <a:lstStyle/>
-          <a:p>
-            <a:pPr indent="0" marL="0">
-              <a:buNone/>
-            </a:pPr>
-            <a:r>
-              <a:rPr lang="en-US" sz="1500" dirty="0">
-                <a:solidFill>
-                  <a:schemeClr val="accent4"/>
-                </a:solidFill>
-              </a:rPr>
-              <a:t>Genre, paket, kupon, atau pengguna yang sudah dipakai hanya bisa dinonaktifkan.</a:t>
-            </a:r>
-            <a:endParaRPr lang="en-US" sz="1500" dirty="0"/>
-          </a:p>
-        </p:txBody>
-      </p:sp>
-      <p:sp>
-        <p:nvSpPr>
-          <p:cNvPr id="17" name="card"/>
-          <p:cNvSpPr/>
-          <p:nvPr/>
-        </p:nvSpPr>
-        <p:spPr>
-          <a:xfrm>
-            <a:off x="6172200" y="3886200"/>
-            <a:ext cx="5440680" cy="1920240"/>
-          </a:xfrm>
-          <a:prstGeom prst="roundRect">
-            <a:avLst>
-              <a:gd name="adj" fmla="val 5714"/>
-            </a:avLst>
-          </a:prstGeom>
-          <a:solidFill>
-            <a:schemeClr val="bg2"/>
-          </a:solidFill>
-          <a:ln w="12700">
-            <a:solidFill>
-              <a:schemeClr val="bg2"/>
-            </a:solidFill>
-            <a:prstDash val="solid"/>
-          </a:ln>
-        </p:spPr>
-      </p:sp>
-      <p:sp>
-        <p:nvSpPr>
-          <p:cNvPr id="18" name="Text 15"/>
-          <p:cNvSpPr txBox="1"/>
-          <p:nvPr/>
-        </p:nvSpPr>
-        <p:spPr>
-          <a:xfrm>
-            <a:off x="6446520" y="4114800"/>
-            <a:ext cx="548640" cy="640080"/>
-          </a:xfrm>
-          <a:prstGeom prst="rect">
-            <a:avLst/>
-          </a:prstGeom>
-          <a:noFill/>
-          <a:ln/>
-        </p:spPr>
-        <p:txBody>
-          <a:bodyPr wrap="square" lIns="0" tIns="0" rIns="0" bIns="0" rtlCol="0" anchor="ctr"/>
-          <a:lstStyle/>
-          <a:p>
-            <a:pPr indent="0" marL="0">
-              <a:buNone/>
-            </a:pPr>
-            <a:r>
-              <a:rPr lang="en-US" sz="3000" b="1" dirty="0">
-                <a:solidFill>
-                  <a:schemeClr val="accent1"/>
-                </a:solidFill>
-                <a:latin typeface="+mj-lt" pitchFamily="34" charset="0"/>
-                <a:ea typeface="+mj-lt" pitchFamily="34" charset="-122"/>
-                <a:cs typeface="+mj-lt" pitchFamily="34" charset="-120"/>
-              </a:rPr>
-              <a:t>4</a:t>
-            </a:r>
-            <a:endParaRPr lang="en-US" sz="3000" dirty="0"/>
-          </a:p>
-        </p:txBody>
-      </p:sp>
-      <p:sp>
-        <p:nvSpPr>
-          <p:cNvPr id="19" name="Text 16"/>
-          <p:cNvSpPr txBox="1"/>
-          <p:nvPr/>
-        </p:nvSpPr>
-        <p:spPr>
-          <a:xfrm>
-            <a:off x="7086600" y="4160520"/>
-            <a:ext cx="4297680" cy="457200"/>
-          </a:xfrm>
-          <a:prstGeom prst="rect">
-            <a:avLst/>
-          </a:prstGeom>
-          <a:noFill/>
-          <a:ln/>
-        </p:spPr>
-        <p:txBody>
-          <a:bodyPr wrap="square" lIns="0" tIns="0" rIns="0" bIns="0" rtlCol="0" anchor="ctr"/>
-          <a:lstStyle/>
-          <a:p>
-            <a:pPr indent="0" marL="0">
-              <a:buNone/>
-            </a:pPr>
-            <a:r>
-              <a:rPr lang="en-US" sz="1800" b="1" dirty="0">
-                <a:solidFill>
-                  <a:schemeClr val="tx1"/>
-                </a:solidFill>
-                <a:latin typeface="+mj-lt" pitchFamily="34" charset="0"/>
-                <a:ea typeface="+mj-lt" pitchFamily="34" charset="-122"/>
-                <a:cs typeface="+mj-lt" pitchFamily="34" charset="-120"/>
-              </a:rPr>
-              <a:t>Episode diperbarui di tempat</a:t>
-            </a:r>
-            <a:endParaRPr lang="en-US" sz="1800" dirty="0"/>
-          </a:p>
-        </p:txBody>
-      </p:sp>
-      <p:sp>
-        <p:nvSpPr>
-          <p:cNvPr id="20" name="Text 17"/>
-          <p:cNvSpPr txBox="1"/>
-          <p:nvPr/>
-        </p:nvSpPr>
-        <p:spPr>
-          <a:xfrm>
-            <a:off x="7086600" y="4709160"/>
-            <a:ext cx="4297680" cy="1097280"/>
-          </a:xfrm>
-          <a:prstGeom prst="rect">
-            <a:avLst/>
-          </a:prstGeom>
-          <a:noFill/>
-          <a:ln/>
-        </p:spPr>
-        <p:txBody>
-          <a:bodyPr wrap="square" lIns="0" tIns="0" rIns="0" bIns="0" rtlCol="0" anchor="t"/>
-          <a:lstStyle/>
-          <a:p>
-            <a:pPr indent="0" marL="0">
-              <a:buNone/>
-            </a:pPr>
-            <a:r>
-              <a:rPr lang="en-US" sz="1500" dirty="0">
-                <a:solidFill>
-                  <a:schemeClr val="accent4"/>
-                </a:solidFill>
-              </a:rPr>
-              <a:t>Baris yang sama dipertahankan, jadi riwayat tontonan tidak terputus.</a:t>
-            </a:r>
-            <a:endParaRPr lang="en-US" sz="1500" dirty="0"/>
-          </a:p>
-        </p:txBody>
-      </p:sp>
+      <p:graphicFrame>
+        <p:nvGraphicFramePr>
+          <p:cNvPr id="11" name="Table 0"/>
+          <p:cNvGraphicFramePr>
+            <a:graphicFrameLocks noGrp="1"/>
+          </p:cNvGraphicFramePr>
+          <p:nvPr>
+            <p:extLst>
+              <p:ext uri="{D42A27DB-BD31-4B8C-83A1-F6EECF244321}">
+                <p14:modId xmlns:p14="http://schemas.microsoft.com/office/powerpoint/2010/main" val="1579011935"/>
+              </p:ext>
+            </p:extLst>
+          </p:nvPr>
+        </p:nvGraphicFramePr>
+        <p:xfrm>
+          <a:off x="548640" y="1508760"/>
+          <a:ext cx="11064240" cy="914400"/>
+        </p:xfrm>
+        <a:graphic>
+          <a:graphicData uri="http://schemas.openxmlformats.org/drawingml/2006/table">
+            <a:tbl>
+              <a:tblPr/>
+              <a:tblGrid>
+                <a:gridCol w="3291840"/>
+                <a:gridCol w="4114800"/>
+                <a:gridCol w="3657600"/>
+              </a:tblGrid>
+              <a:tr h="0">
+                <a:tc>
+                  <a:txBody>
+                    <a:bodyPr/>
+                    <a:lstStyle/>
+                    <a:p>
+                      <a:pPr indent="0" marL="0">
+                        <a:buNone/>
+                      </a:pPr>
+                      <a:r>
+                        <a:rPr lang="en-US" sz="1500" b="1" dirty="0">
+                          <a:solidFill>
+                            <a:srgbClr val="1E9E57"/>
+                          </a:solidFill>
+                        </a:rPr>
+                        <a:t>Keputusan</a:t>
+                      </a:r>
+                      <a:endParaRPr lang="en-US" sz="1500" dirty="0"/>
+                    </a:p>
+                  </a:txBody>
+                  <a:tcPr marL="164592" marR="164592" marT="182880" marB="182880" anchor="t">
+                    <a:lnL w="9525" cap="flat" cmpd="sng" algn="ctr">
+                      <a:solidFill>
+                        <a:srgbClr val="D6E2DA"/>
+                      </a:solidFill>
+                      <a:prstDash val="solid"/>
+                      <a:round/>
+                      <a:headEnd type="none" w="med" len="med"/>
+                      <a:tailEnd type="none" w="med" len="med"/>
+                    </a:lnL>
+                    <a:lnR w="9525" cap="flat" cmpd="sng" algn="ctr">
+                      <a:solidFill>
+                        <a:srgbClr val="D6E2DA"/>
+                      </a:solidFill>
+                      <a:prstDash val="solid"/>
+                      <a:round/>
+                      <a:headEnd type="none" w="med" len="med"/>
+                      <a:tailEnd type="none" w="med" len="med"/>
+                    </a:lnR>
+                    <a:lnT w="9525" cap="flat" cmpd="sng" algn="ctr">
+                      <a:solidFill>
+                        <a:srgbClr val="D6E2DA"/>
+                      </a:solidFill>
+                      <a:prstDash val="solid"/>
+                      <a:round/>
+                      <a:headEnd type="none" w="med" len="med"/>
+                      <a:tailEnd type="none" w="med" len="med"/>
+                    </a:lnT>
+                    <a:lnB w="9525" cap="flat" cmpd="sng" algn="ctr">
+                      <a:solidFill>
+                        <a:srgbClr val="D6E2DA"/>
+                      </a:solidFill>
+                      <a:prstDash val="solid"/>
+                      <a:round/>
+                      <a:headEnd type="none" w="med" len="med"/>
+                      <a:tailEnd type="none" w="med" len="med"/>
+                    </a:lnB>
+                    <a:solidFill>
+                      <a:srgbClr val="EEF3EF"/>
+                    </a:solidFill>
+                  </a:tcPr>
+                </a:tc>
+                <a:tc>
+                  <a:txBody>
+                    <a:bodyPr/>
+                    <a:lstStyle/>
+                    <a:p>
+                      <a:pPr indent="0" marL="0">
+                        <a:buNone/>
+                      </a:pPr>
+                      <a:r>
+                        <a:rPr lang="en-US" sz="1500" b="1" dirty="0">
+                          <a:solidFill>
+                            <a:srgbClr val="1E9E57"/>
+                          </a:solidFill>
+                        </a:rPr>
+                        <a:t>Kenapa</a:t>
+                      </a:r>
+                      <a:endParaRPr lang="en-US" sz="1500" dirty="0"/>
+                    </a:p>
+                  </a:txBody>
+                  <a:tcPr marL="164592" marR="164592" marT="182880" marB="182880" anchor="t">
+                    <a:lnL w="9525" cap="flat" cmpd="sng" algn="ctr">
+                      <a:solidFill>
+                        <a:srgbClr val="D6E2DA"/>
+                      </a:solidFill>
+                      <a:prstDash val="solid"/>
+                      <a:round/>
+                      <a:headEnd type="none" w="med" len="med"/>
+                      <a:tailEnd type="none" w="med" len="med"/>
+                    </a:lnL>
+                    <a:lnR w="9525" cap="flat" cmpd="sng" algn="ctr">
+                      <a:solidFill>
+                        <a:srgbClr val="D6E2DA"/>
+                      </a:solidFill>
+                      <a:prstDash val="solid"/>
+                      <a:round/>
+                      <a:headEnd type="none" w="med" len="med"/>
+                      <a:tailEnd type="none" w="med" len="med"/>
+                    </a:lnR>
+                    <a:lnT w="9525" cap="flat" cmpd="sng" algn="ctr">
+                      <a:solidFill>
+                        <a:srgbClr val="D6E2DA"/>
+                      </a:solidFill>
+                      <a:prstDash val="solid"/>
+                      <a:round/>
+                      <a:headEnd type="none" w="med" len="med"/>
+                      <a:tailEnd type="none" w="med" len="med"/>
+                    </a:lnT>
+                    <a:lnB w="9525" cap="flat" cmpd="sng" algn="ctr">
+                      <a:solidFill>
+                        <a:srgbClr val="D6E2DA"/>
+                      </a:solidFill>
+                      <a:prstDash val="solid"/>
+                      <a:round/>
+                      <a:headEnd type="none" w="med" len="med"/>
+                      <a:tailEnd type="none" w="med" len="med"/>
+                    </a:lnB>
+                    <a:solidFill>
+                      <a:srgbClr val="EEF3EF"/>
+                    </a:solidFill>
+                  </a:tcPr>
+                </a:tc>
+                <a:tc>
+                  <a:txBody>
+                    <a:bodyPr/>
+                    <a:lstStyle/>
+                    <a:p>
+                      <a:pPr indent="0" marL="0">
+                        <a:buNone/>
+                      </a:pPr>
+                      <a:r>
+                        <a:rPr lang="en-US" sz="1500" b="1" dirty="0">
+                          <a:solidFill>
+                            <a:srgbClr val="1E9E57"/>
+                          </a:solidFill>
+                        </a:rPr>
+                        <a:t>Harganya</a:t>
+                      </a:r>
+                      <a:endParaRPr lang="en-US" sz="1500" dirty="0"/>
+                    </a:p>
+                  </a:txBody>
+                  <a:tcPr marL="164592" marR="164592" marT="182880" marB="182880" anchor="t">
+                    <a:lnL w="9525" cap="flat" cmpd="sng" algn="ctr">
+                      <a:solidFill>
+                        <a:srgbClr val="D6E2DA"/>
+                      </a:solidFill>
+                      <a:prstDash val="solid"/>
+                      <a:round/>
+                      <a:headEnd type="none" w="med" len="med"/>
+                      <a:tailEnd type="none" w="med" len="med"/>
+                    </a:lnL>
+                    <a:lnR w="9525" cap="flat" cmpd="sng" algn="ctr">
+                      <a:solidFill>
+                        <a:srgbClr val="D6E2DA"/>
+                      </a:solidFill>
+                      <a:prstDash val="solid"/>
+                      <a:round/>
+                      <a:headEnd type="none" w="med" len="med"/>
+                      <a:tailEnd type="none" w="med" len="med"/>
+                    </a:lnR>
+                    <a:lnT w="9525" cap="flat" cmpd="sng" algn="ctr">
+                      <a:solidFill>
+                        <a:srgbClr val="D6E2DA"/>
+                      </a:solidFill>
+                      <a:prstDash val="solid"/>
+                      <a:round/>
+                      <a:headEnd type="none" w="med" len="med"/>
+                      <a:tailEnd type="none" w="med" len="med"/>
+                    </a:lnT>
+                    <a:lnB w="9525" cap="flat" cmpd="sng" algn="ctr">
+                      <a:solidFill>
+                        <a:srgbClr val="D6E2DA"/>
+                      </a:solidFill>
+                      <a:prstDash val="solid"/>
+                      <a:round/>
+                      <a:headEnd type="none" w="med" len="med"/>
+                      <a:tailEnd type="none" w="med" len="med"/>
+                    </a:lnB>
+                    <a:solidFill>
+                      <a:srgbClr val="EEF3EF"/>
+                    </a:solidFill>
+                  </a:tcPr>
+                </a:tc>
+              </a:tr>
+              <a:tr h="0">
+                <a:tc>
+                  <a:txBody>
+                    <a:bodyPr/>
+                    <a:lstStyle/>
+                    <a:p>
+                      <a:pPr indent="0" marL="0">
+                        <a:buNone/>
+                      </a:pPr>
+                      <a:r>
+                        <a:rPr lang="en-US" sz="1700" b="1" dirty="0">
+                          <a:solidFill>
+                            <a:srgbClr val="15211B"/>
+                          </a:solidFill>
+                        </a:rPr>
+                        <a:t>subscription_ends_on disimpan di users</a:t>
+                      </a:r>
+                      <a:endParaRPr lang="en-US" sz="1700" dirty="0"/>
+                    </a:p>
+                  </a:txBody>
+                  <a:tcPr marL="164592" marR="164592" marT="182880" marB="182880" anchor="t">
+                    <a:lnL w="9525" cap="flat" cmpd="sng" algn="ctr">
+                      <a:solidFill>
+                        <a:srgbClr val="D6E2DA"/>
+                      </a:solidFill>
+                      <a:prstDash val="solid"/>
+                      <a:round/>
+                      <a:headEnd type="none" w="med" len="med"/>
+                      <a:tailEnd type="none" w="med" len="med"/>
+                    </a:lnL>
+                    <a:lnR w="9525" cap="flat" cmpd="sng" algn="ctr">
+                      <a:solidFill>
+                        <a:srgbClr val="D6E2DA"/>
+                      </a:solidFill>
+                      <a:prstDash val="solid"/>
+                      <a:round/>
+                      <a:headEnd type="none" w="med" len="med"/>
+                      <a:tailEnd type="none" w="med" len="med"/>
+                    </a:lnR>
+                    <a:lnT w="9525" cap="flat" cmpd="sng" algn="ctr">
+                      <a:solidFill>
+                        <a:srgbClr val="D6E2DA"/>
+                      </a:solidFill>
+                      <a:prstDash val="solid"/>
+                      <a:round/>
+                      <a:headEnd type="none" w="med" len="med"/>
+                      <a:tailEnd type="none" w="med" len="med"/>
+                    </a:lnT>
+                    <a:lnB w="9525" cap="flat" cmpd="sng" algn="ctr">
+                      <a:solidFill>
+                        <a:srgbClr val="D6E2DA"/>
+                      </a:solidFill>
+                      <a:prstDash val="solid"/>
+                      <a:round/>
+                      <a:headEnd type="none" w="med" len="med"/>
+                      <a:tailEnd type="none" w="med" len="med"/>
+                    </a:lnB>
+                  </a:tcPr>
+                </a:tc>
+                <a:tc>
+                  <a:txBody>
+                    <a:bodyPr/>
+                    <a:lstStyle/>
+                    <a:p>
+                      <a:pPr indent="0" marL="0">
+                        <a:buNone/>
+                      </a:pPr>
+                      <a:r>
+                        <a:rPr lang="en-US" sz="1700" dirty="0">
+                          <a:solidFill>
+                            <a:srgbClr val="15211B"/>
+                          </a:solidFill>
+                        </a:rPr>
+                        <a:t>API mengecek akses di setiap pemutaran; satu kolom ber-index cukup</a:t>
+                      </a:r>
+                      <a:endParaRPr lang="en-US" sz="1700" dirty="0"/>
+                    </a:p>
+                  </a:txBody>
+                  <a:tcPr marL="164592" marR="164592" marT="182880" marB="182880" anchor="t">
+                    <a:lnL w="9525" cap="flat" cmpd="sng" algn="ctr">
+                      <a:solidFill>
+                        <a:srgbClr val="D6E2DA"/>
+                      </a:solidFill>
+                      <a:prstDash val="solid"/>
+                      <a:round/>
+                      <a:headEnd type="none" w="med" len="med"/>
+                      <a:tailEnd type="none" w="med" len="med"/>
+                    </a:lnL>
+                    <a:lnR w="9525" cap="flat" cmpd="sng" algn="ctr">
+                      <a:solidFill>
+                        <a:srgbClr val="D6E2DA"/>
+                      </a:solidFill>
+                      <a:prstDash val="solid"/>
+                      <a:round/>
+                      <a:headEnd type="none" w="med" len="med"/>
+                      <a:tailEnd type="none" w="med" len="med"/>
+                    </a:lnR>
+                    <a:lnT w="9525" cap="flat" cmpd="sng" algn="ctr">
+                      <a:solidFill>
+                        <a:srgbClr val="D6E2DA"/>
+                      </a:solidFill>
+                      <a:prstDash val="solid"/>
+                      <a:round/>
+                      <a:headEnd type="none" w="med" len="med"/>
+                      <a:tailEnd type="none" w="med" len="med"/>
+                    </a:lnT>
+                    <a:lnB w="9525" cap="flat" cmpd="sng" algn="ctr">
+                      <a:solidFill>
+                        <a:srgbClr val="D6E2DA"/>
+                      </a:solidFill>
+                      <a:prstDash val="solid"/>
+                      <a:round/>
+                      <a:headEnd type="none" w="med" len="med"/>
+                      <a:tailEnd type="none" w="med" len="med"/>
+                    </a:lnB>
+                  </a:tcPr>
+                </a:tc>
+                <a:tc>
+                  <a:txBody>
+                    <a:bodyPr/>
+                    <a:lstStyle/>
+                    <a:p>
+                      <a:pPr indent="0" marL="0">
+                        <a:buNone/>
+                      </a:pPr>
+                      <a:r>
+                        <a:rPr lang="en-US" sz="1700" dirty="0">
+                          <a:solidFill>
+                            <a:srgbClr val="15211B"/>
+                          </a:solidFill>
+                        </a:rPr>
+                        <a:t>Data ganda; hanya SubscriptionService yang boleh mengubahnya</a:t>
+                      </a:r>
+                      <a:endParaRPr lang="en-US" sz="1700" dirty="0"/>
+                    </a:p>
+                  </a:txBody>
+                  <a:tcPr marL="164592" marR="164592" marT="182880" marB="182880" anchor="t">
+                    <a:lnL w="9525" cap="flat" cmpd="sng" algn="ctr">
+                      <a:solidFill>
+                        <a:srgbClr val="D6E2DA"/>
+                      </a:solidFill>
+                      <a:prstDash val="solid"/>
+                      <a:round/>
+                      <a:headEnd type="none" w="med" len="med"/>
+                      <a:tailEnd type="none" w="med" len="med"/>
+                    </a:lnL>
+                    <a:lnR w="9525" cap="flat" cmpd="sng" algn="ctr">
+                      <a:solidFill>
+                        <a:srgbClr val="D6E2DA"/>
+                      </a:solidFill>
+                      <a:prstDash val="solid"/>
+                      <a:round/>
+                      <a:headEnd type="none" w="med" len="med"/>
+                      <a:tailEnd type="none" w="med" len="med"/>
+                    </a:lnR>
+                    <a:lnT w="9525" cap="flat" cmpd="sng" algn="ctr">
+                      <a:solidFill>
+                        <a:srgbClr val="D6E2DA"/>
+                      </a:solidFill>
+                      <a:prstDash val="solid"/>
+                      <a:round/>
+                      <a:headEnd type="none" w="med" len="med"/>
+                      <a:tailEnd type="none" w="med" len="med"/>
+                    </a:lnT>
+                    <a:lnB w="9525" cap="flat" cmpd="sng" algn="ctr">
+                      <a:solidFill>
+                        <a:srgbClr val="D6E2DA"/>
+                      </a:solidFill>
+                      <a:prstDash val="solid"/>
+                      <a:round/>
+                      <a:headEnd type="none" w="med" len="med"/>
+                      <a:tailEnd type="none" w="med" len="med"/>
+                    </a:lnB>
+                  </a:tcPr>
+                </a:tc>
+              </a:tr>
+              <a:tr h="0">
+                <a:tc>
+                  <a:txBody>
+                    <a:bodyPr/>
+                    <a:lstStyle/>
+                    <a:p>
+                      <a:pPr indent="0" marL="0">
+                        <a:buNone/>
+                      </a:pPr>
+                      <a:r>
+                        <a:rPr lang="en-US" sz="1700" b="1" dirty="0">
+                          <a:solidFill>
+                            <a:srgbClr val="15211B"/>
+                          </a:solidFill>
+                        </a:rPr>
+                        <a:t>Pembayaran tidak bisa diedit</a:t>
+                      </a:r>
+                      <a:endParaRPr lang="en-US" sz="1700" dirty="0"/>
+                    </a:p>
+                  </a:txBody>
+                  <a:tcPr marL="164592" marR="164592" marT="182880" marB="182880" anchor="t">
+                    <a:lnL w="9525" cap="flat" cmpd="sng" algn="ctr">
+                      <a:solidFill>
+                        <a:srgbClr val="D6E2DA"/>
+                      </a:solidFill>
+                      <a:prstDash val="solid"/>
+                      <a:round/>
+                      <a:headEnd type="none" w="med" len="med"/>
+                      <a:tailEnd type="none" w="med" len="med"/>
+                    </a:lnL>
+                    <a:lnR w="9525" cap="flat" cmpd="sng" algn="ctr">
+                      <a:solidFill>
+                        <a:srgbClr val="D6E2DA"/>
+                      </a:solidFill>
+                      <a:prstDash val="solid"/>
+                      <a:round/>
+                      <a:headEnd type="none" w="med" len="med"/>
+                      <a:tailEnd type="none" w="med" len="med"/>
+                    </a:lnR>
+                    <a:lnT w="9525" cap="flat" cmpd="sng" algn="ctr">
+                      <a:solidFill>
+                        <a:srgbClr val="D6E2DA"/>
+                      </a:solidFill>
+                      <a:prstDash val="solid"/>
+                      <a:round/>
+                      <a:headEnd type="none" w="med" len="med"/>
+                      <a:tailEnd type="none" w="med" len="med"/>
+                    </a:lnT>
+                    <a:lnB w="9525" cap="flat" cmpd="sng" algn="ctr">
+                      <a:solidFill>
+                        <a:srgbClr val="D6E2DA"/>
+                      </a:solidFill>
+                      <a:prstDash val="solid"/>
+                      <a:round/>
+                      <a:headEnd type="none" w="med" len="med"/>
+                      <a:tailEnd type="none" w="med" len="med"/>
+                    </a:lnB>
+                  </a:tcPr>
+                </a:tc>
+                <a:tc>
+                  <a:txBody>
+                    <a:bodyPr/>
+                    <a:lstStyle/>
+                    <a:p>
+                      <a:pPr indent="0" marL="0">
+                        <a:buNone/>
+                      </a:pPr>
+                      <a:r>
+                        <a:rPr lang="en-US" sz="1700" dirty="0">
+                          <a:solidFill>
+                            <a:srgbClr val="15211B"/>
+                          </a:solidFill>
+                        </a:rPr>
+                        <a:t>Langganan dan sewa adalah catatan keuangan</a:t>
+                      </a:r>
+                      <a:endParaRPr lang="en-US" sz="1700" dirty="0"/>
+                    </a:p>
+                  </a:txBody>
+                  <a:tcPr marL="164592" marR="164592" marT="182880" marB="182880" anchor="t">
+                    <a:lnL w="9525" cap="flat" cmpd="sng" algn="ctr">
+                      <a:solidFill>
+                        <a:srgbClr val="D6E2DA"/>
+                      </a:solidFill>
+                      <a:prstDash val="solid"/>
+                      <a:round/>
+                      <a:headEnd type="none" w="med" len="med"/>
+                      <a:tailEnd type="none" w="med" len="med"/>
+                    </a:lnL>
+                    <a:lnR w="9525" cap="flat" cmpd="sng" algn="ctr">
+                      <a:solidFill>
+                        <a:srgbClr val="D6E2DA"/>
+                      </a:solidFill>
+                      <a:prstDash val="solid"/>
+                      <a:round/>
+                      <a:headEnd type="none" w="med" len="med"/>
+                      <a:tailEnd type="none" w="med" len="med"/>
+                    </a:lnR>
+                    <a:lnT w="9525" cap="flat" cmpd="sng" algn="ctr">
+                      <a:solidFill>
+                        <a:srgbClr val="D6E2DA"/>
+                      </a:solidFill>
+                      <a:prstDash val="solid"/>
+                      <a:round/>
+                      <a:headEnd type="none" w="med" len="med"/>
+                      <a:tailEnd type="none" w="med" len="med"/>
+                    </a:lnT>
+                    <a:lnB w="9525" cap="flat" cmpd="sng" algn="ctr">
+                      <a:solidFill>
+                        <a:srgbClr val="D6E2DA"/>
+                      </a:solidFill>
+                      <a:prstDash val="solid"/>
+                      <a:round/>
+                      <a:headEnd type="none" w="med" len="med"/>
+                      <a:tailEnd type="none" w="med" len="med"/>
+                    </a:lnB>
+                  </a:tcPr>
+                </a:tc>
+                <a:tc>
+                  <a:txBody>
+                    <a:bodyPr/>
+                    <a:lstStyle/>
+                    <a:p>
+                      <a:pPr indent="0" marL="0">
+                        <a:buNone/>
+                      </a:pPr>
+                      <a:r>
+                        <a:rPr lang="en-US" sz="1700" dirty="0">
+                          <a:solidFill>
+                            <a:srgbClr val="15211B"/>
+                          </a:solidFill>
+                        </a:rPr>
+                        <a:t>Koreksi harus berupa entri baru</a:t>
+                      </a:r>
+                      <a:endParaRPr lang="en-US" sz="1700" dirty="0"/>
+                    </a:p>
+                  </a:txBody>
+                  <a:tcPr marL="164592" marR="164592" marT="182880" marB="182880" anchor="t">
+                    <a:lnL w="9525" cap="flat" cmpd="sng" algn="ctr">
+                      <a:solidFill>
+                        <a:srgbClr val="D6E2DA"/>
+                      </a:solidFill>
+                      <a:prstDash val="solid"/>
+                      <a:round/>
+                      <a:headEnd type="none" w="med" len="med"/>
+                      <a:tailEnd type="none" w="med" len="med"/>
+                    </a:lnL>
+                    <a:lnR w="9525" cap="flat" cmpd="sng" algn="ctr">
+                      <a:solidFill>
+                        <a:srgbClr val="D6E2DA"/>
+                      </a:solidFill>
+                      <a:prstDash val="solid"/>
+                      <a:round/>
+                      <a:headEnd type="none" w="med" len="med"/>
+                      <a:tailEnd type="none" w="med" len="med"/>
+                    </a:lnR>
+                    <a:lnT w="9525" cap="flat" cmpd="sng" algn="ctr">
+                      <a:solidFill>
+                        <a:srgbClr val="D6E2DA"/>
+                      </a:solidFill>
+                      <a:prstDash val="solid"/>
+                      <a:round/>
+                      <a:headEnd type="none" w="med" len="med"/>
+                      <a:tailEnd type="none" w="med" len="med"/>
+                    </a:lnT>
+                    <a:lnB w="9525" cap="flat" cmpd="sng" algn="ctr">
+                      <a:solidFill>
+                        <a:srgbClr val="D6E2DA"/>
+                      </a:solidFill>
+                      <a:prstDash val="solid"/>
+                      <a:round/>
+                      <a:headEnd type="none" w="med" len="med"/>
+                      <a:tailEnd type="none" w="med" len="med"/>
+                    </a:lnB>
+                  </a:tcPr>
+                </a:tc>
+              </a:tr>
+              <a:tr h="0">
+                <a:tc>
+                  <a:txBody>
+                    <a:bodyPr/>
+                    <a:lstStyle/>
+                    <a:p>
+                      <a:pPr indent="0" marL="0">
+                        <a:buNone/>
+                      </a:pPr>
+                      <a:r>
+                        <a:rPr lang="en-US" sz="1700" b="1" dirty="0">
+                          <a:solidFill>
+                            <a:srgbClr val="15211B"/>
+                          </a:solidFill>
+                        </a:rPr>
+                        <a:t>Nonaktifkan, bukan hapus</a:t>
+                      </a:r>
+                      <a:endParaRPr lang="en-US" sz="1700" dirty="0"/>
+                    </a:p>
+                  </a:txBody>
+                  <a:tcPr marL="164592" marR="164592" marT="182880" marB="182880" anchor="t">
+                    <a:lnL w="9525" cap="flat" cmpd="sng" algn="ctr">
+                      <a:solidFill>
+                        <a:srgbClr val="D6E2DA"/>
+                      </a:solidFill>
+                      <a:prstDash val="solid"/>
+                      <a:round/>
+                      <a:headEnd type="none" w="med" len="med"/>
+                      <a:tailEnd type="none" w="med" len="med"/>
+                    </a:lnL>
+                    <a:lnR w="9525" cap="flat" cmpd="sng" algn="ctr">
+                      <a:solidFill>
+                        <a:srgbClr val="D6E2DA"/>
+                      </a:solidFill>
+                      <a:prstDash val="solid"/>
+                      <a:round/>
+                      <a:headEnd type="none" w="med" len="med"/>
+                      <a:tailEnd type="none" w="med" len="med"/>
+                    </a:lnR>
+                    <a:lnT w="9525" cap="flat" cmpd="sng" algn="ctr">
+                      <a:solidFill>
+                        <a:srgbClr val="D6E2DA"/>
+                      </a:solidFill>
+                      <a:prstDash val="solid"/>
+                      <a:round/>
+                      <a:headEnd type="none" w="med" len="med"/>
+                      <a:tailEnd type="none" w="med" len="med"/>
+                    </a:lnT>
+                    <a:lnB w="9525" cap="flat" cmpd="sng" algn="ctr">
+                      <a:solidFill>
+                        <a:srgbClr val="D6E2DA"/>
+                      </a:solidFill>
+                      <a:prstDash val="solid"/>
+                      <a:round/>
+                      <a:headEnd type="none" w="med" len="med"/>
+                      <a:tailEnd type="none" w="med" len="med"/>
+                    </a:lnB>
+                  </a:tcPr>
+                </a:tc>
+                <a:tc>
+                  <a:txBody>
+                    <a:bodyPr/>
+                    <a:lstStyle/>
+                    <a:p>
+                      <a:pPr indent="0" marL="0">
+                        <a:buNone/>
+                      </a:pPr>
+                      <a:r>
+                        <a:rPr lang="en-US" sz="1700" dirty="0">
+                          <a:solidFill>
+                            <a:srgbClr val="15211B"/>
+                          </a:solidFill>
+                        </a:rPr>
+                        <a:t>Genre, paket, atau pengguna yang dipakai tetap punya riwayat</a:t>
+                      </a:r>
+                      <a:endParaRPr lang="en-US" sz="1700" dirty="0"/>
+                    </a:p>
+                  </a:txBody>
+                  <a:tcPr marL="164592" marR="164592" marT="182880" marB="182880" anchor="t">
+                    <a:lnL w="9525" cap="flat" cmpd="sng" algn="ctr">
+                      <a:solidFill>
+                        <a:srgbClr val="D6E2DA"/>
+                      </a:solidFill>
+                      <a:prstDash val="solid"/>
+                      <a:round/>
+                      <a:headEnd type="none" w="med" len="med"/>
+                      <a:tailEnd type="none" w="med" len="med"/>
+                    </a:lnL>
+                    <a:lnR w="9525" cap="flat" cmpd="sng" algn="ctr">
+                      <a:solidFill>
+                        <a:srgbClr val="D6E2DA"/>
+                      </a:solidFill>
+                      <a:prstDash val="solid"/>
+                      <a:round/>
+                      <a:headEnd type="none" w="med" len="med"/>
+                      <a:tailEnd type="none" w="med" len="med"/>
+                    </a:lnR>
+                    <a:lnT w="9525" cap="flat" cmpd="sng" algn="ctr">
+                      <a:solidFill>
+                        <a:srgbClr val="D6E2DA"/>
+                      </a:solidFill>
+                      <a:prstDash val="solid"/>
+                      <a:round/>
+                      <a:headEnd type="none" w="med" len="med"/>
+                      <a:tailEnd type="none" w="med" len="med"/>
+                    </a:lnT>
+                    <a:lnB w="9525" cap="flat" cmpd="sng" algn="ctr">
+                      <a:solidFill>
+                        <a:srgbClr val="D6E2DA"/>
+                      </a:solidFill>
+                      <a:prstDash val="solid"/>
+                      <a:round/>
+                      <a:headEnd type="none" w="med" len="med"/>
+                      <a:tailEnd type="none" w="med" len="med"/>
+                    </a:lnB>
+                  </a:tcPr>
+                </a:tc>
+                <a:tc>
+                  <a:txBody>
+                    <a:bodyPr/>
+                    <a:lstStyle/>
+                    <a:p>
+                      <a:pPr indent="0" marL="0">
+                        <a:buNone/>
+                      </a:pPr>
+                      <a:r>
+                        <a:rPr lang="en-US" sz="1700" dirty="0">
+                          <a:solidFill>
+                            <a:srgbClr val="15211B"/>
+                          </a:solidFill>
+                        </a:rPr>
+                        <a:t>Daftar perlu filter aktif</a:t>
+                      </a:r>
+                      <a:endParaRPr lang="en-US" sz="1700" dirty="0"/>
+                    </a:p>
+                  </a:txBody>
+                  <a:tcPr marL="164592" marR="164592" marT="182880" marB="182880" anchor="t">
+                    <a:lnL w="9525" cap="flat" cmpd="sng" algn="ctr">
+                      <a:solidFill>
+                        <a:srgbClr val="D6E2DA"/>
+                      </a:solidFill>
+                      <a:prstDash val="solid"/>
+                      <a:round/>
+                      <a:headEnd type="none" w="med" len="med"/>
+                      <a:tailEnd type="none" w="med" len="med"/>
+                    </a:lnL>
+                    <a:lnR w="9525" cap="flat" cmpd="sng" algn="ctr">
+                      <a:solidFill>
+                        <a:srgbClr val="D6E2DA"/>
+                      </a:solidFill>
+                      <a:prstDash val="solid"/>
+                      <a:round/>
+                      <a:headEnd type="none" w="med" len="med"/>
+                      <a:tailEnd type="none" w="med" len="med"/>
+                    </a:lnR>
+                    <a:lnT w="9525" cap="flat" cmpd="sng" algn="ctr">
+                      <a:solidFill>
+                        <a:srgbClr val="D6E2DA"/>
+                      </a:solidFill>
+                      <a:prstDash val="solid"/>
+                      <a:round/>
+                      <a:headEnd type="none" w="med" len="med"/>
+                      <a:tailEnd type="none" w="med" len="med"/>
+                    </a:lnT>
+                    <a:lnB w="9525" cap="flat" cmpd="sng" algn="ctr">
+                      <a:solidFill>
+                        <a:srgbClr val="D6E2DA"/>
+                      </a:solidFill>
+                      <a:prstDash val="solid"/>
+                      <a:round/>
+                      <a:headEnd type="none" w="med" len="med"/>
+                      <a:tailEnd type="none" w="med" len="med"/>
+                    </a:lnB>
+                  </a:tcPr>
+                </a:tc>
+              </a:tr>
+              <a:tr h="0">
+                <a:tc>
+                  <a:txBody>
+                    <a:bodyPr/>
+                    <a:lstStyle/>
+                    <a:p>
+                      <a:pPr indent="0" marL="0">
+                        <a:buNone/>
+                      </a:pPr>
+                      <a:r>
+                        <a:rPr lang="en-US" sz="1700" b="1" dirty="0">
+                          <a:solidFill>
+                            <a:srgbClr val="15211B"/>
+                          </a:solidFill>
+                        </a:rPr>
+                        <a:t>Episode diperbarui di tempat</a:t>
+                      </a:r>
+                      <a:endParaRPr lang="en-US" sz="1700" dirty="0"/>
+                    </a:p>
+                  </a:txBody>
+                  <a:tcPr marL="164592" marR="164592" marT="182880" marB="182880" anchor="t">
+                    <a:lnL w="9525" cap="flat" cmpd="sng" algn="ctr">
+                      <a:solidFill>
+                        <a:srgbClr val="D6E2DA"/>
+                      </a:solidFill>
+                      <a:prstDash val="solid"/>
+                      <a:round/>
+                      <a:headEnd type="none" w="med" len="med"/>
+                      <a:tailEnd type="none" w="med" len="med"/>
+                    </a:lnL>
+                    <a:lnR w="9525" cap="flat" cmpd="sng" algn="ctr">
+                      <a:solidFill>
+                        <a:srgbClr val="D6E2DA"/>
+                      </a:solidFill>
+                      <a:prstDash val="solid"/>
+                      <a:round/>
+                      <a:headEnd type="none" w="med" len="med"/>
+                      <a:tailEnd type="none" w="med" len="med"/>
+                    </a:lnR>
+                    <a:lnT w="9525" cap="flat" cmpd="sng" algn="ctr">
+                      <a:solidFill>
+                        <a:srgbClr val="D6E2DA"/>
+                      </a:solidFill>
+                      <a:prstDash val="solid"/>
+                      <a:round/>
+                      <a:headEnd type="none" w="med" len="med"/>
+                      <a:tailEnd type="none" w="med" len="med"/>
+                    </a:lnT>
+                    <a:lnB w="9525" cap="flat" cmpd="sng" algn="ctr">
+                      <a:solidFill>
+                        <a:srgbClr val="D6E2DA"/>
+                      </a:solidFill>
+                      <a:prstDash val="solid"/>
+                      <a:round/>
+                      <a:headEnd type="none" w="med" len="med"/>
+                      <a:tailEnd type="none" w="med" len="med"/>
+                    </a:lnB>
+                  </a:tcPr>
+                </a:tc>
+                <a:tc>
+                  <a:txBody>
+                    <a:bodyPr/>
+                    <a:lstStyle/>
+                    <a:p>
+                      <a:pPr indent="0" marL="0">
+                        <a:buNone/>
+                      </a:pPr>
+                      <a:r>
+                        <a:rPr lang="en-US" sz="1700" dirty="0">
+                          <a:solidFill>
+                            <a:srgbClr val="15211B"/>
+                          </a:solidFill>
+                        </a:rPr>
+                        <a:t>Riwayat tontonan tetap menempel ke baris yang sama</a:t>
+                      </a:r>
+                      <a:endParaRPr lang="en-US" sz="1700" dirty="0"/>
+                    </a:p>
+                  </a:txBody>
+                  <a:tcPr marL="164592" marR="164592" marT="182880" marB="182880" anchor="t">
+                    <a:lnL w="9525" cap="flat" cmpd="sng" algn="ctr">
+                      <a:solidFill>
+                        <a:srgbClr val="D6E2DA"/>
+                      </a:solidFill>
+                      <a:prstDash val="solid"/>
+                      <a:round/>
+                      <a:headEnd type="none" w="med" len="med"/>
+                      <a:tailEnd type="none" w="med" len="med"/>
+                    </a:lnL>
+                    <a:lnR w="9525" cap="flat" cmpd="sng" algn="ctr">
+                      <a:solidFill>
+                        <a:srgbClr val="D6E2DA"/>
+                      </a:solidFill>
+                      <a:prstDash val="solid"/>
+                      <a:round/>
+                      <a:headEnd type="none" w="med" len="med"/>
+                      <a:tailEnd type="none" w="med" len="med"/>
+                    </a:lnR>
+                    <a:lnT w="9525" cap="flat" cmpd="sng" algn="ctr">
+                      <a:solidFill>
+                        <a:srgbClr val="D6E2DA"/>
+                      </a:solidFill>
+                      <a:prstDash val="solid"/>
+                      <a:round/>
+                      <a:headEnd type="none" w="med" len="med"/>
+                      <a:tailEnd type="none" w="med" len="med"/>
+                    </a:lnT>
+                    <a:lnB w="9525" cap="flat" cmpd="sng" algn="ctr">
+                      <a:solidFill>
+                        <a:srgbClr val="D6E2DA"/>
+                      </a:solidFill>
+                      <a:prstDash val="solid"/>
+                      <a:round/>
+                      <a:headEnd type="none" w="med" len="med"/>
+                      <a:tailEnd type="none" w="med" len="med"/>
+                    </a:lnB>
+                  </a:tcPr>
+                </a:tc>
+                <a:tc>
+                  <a:txBody>
+                    <a:bodyPr/>
+                    <a:lstStyle/>
+                    <a:p>
+                      <a:pPr indent="0" marL="0">
+                        <a:buNone/>
+                      </a:pPr>
+                      <a:r>
+                        <a:rPr lang="en-US" sz="1700" dirty="0">
+                          <a:solidFill>
+                            <a:srgbClr val="15211B"/>
+                          </a:solidFill>
+                        </a:rPr>
+                        <a:t>Kode simpan lebih rumit daripada hapus lalu buat ulang</a:t>
+                      </a:r>
+                      <a:endParaRPr lang="en-US" sz="1700" dirty="0"/>
+                    </a:p>
+                  </a:txBody>
+                  <a:tcPr marL="164592" marR="164592" marT="182880" marB="182880" anchor="t">
+                    <a:lnL w="9525" cap="flat" cmpd="sng" algn="ctr">
+                      <a:solidFill>
+                        <a:srgbClr val="D6E2DA"/>
+                      </a:solidFill>
+                      <a:prstDash val="solid"/>
+                      <a:round/>
+                      <a:headEnd type="none" w="med" len="med"/>
+                      <a:tailEnd type="none" w="med" len="med"/>
+                    </a:lnL>
+                    <a:lnR w="9525" cap="flat" cmpd="sng" algn="ctr">
+                      <a:solidFill>
+                        <a:srgbClr val="D6E2DA"/>
+                      </a:solidFill>
+                      <a:prstDash val="solid"/>
+                      <a:round/>
+                      <a:headEnd type="none" w="med" len="med"/>
+                      <a:tailEnd type="none" w="med" len="med"/>
+                    </a:lnR>
+                    <a:lnT w="9525" cap="flat" cmpd="sng" algn="ctr">
+                      <a:solidFill>
+                        <a:srgbClr val="D6E2DA"/>
+                      </a:solidFill>
+                      <a:prstDash val="solid"/>
+                      <a:round/>
+                      <a:headEnd type="none" w="med" len="med"/>
+                      <a:tailEnd type="none" w="med" len="med"/>
+                    </a:lnT>
+                    <a:lnB w="9525" cap="flat" cmpd="sng" algn="ctr">
+                      <a:solidFill>
+                        <a:srgbClr val="D6E2DA"/>
+                      </a:solidFill>
+                      <a:prstDash val="solid"/>
+                      <a:round/>
+                      <a:headEnd type="none" w="med" len="med"/>
+                      <a:tailEnd type="none" w="med" len="med"/>
+                    </a:lnB>
+                  </a:tcPr>
+                </a:tc>
+              </a:tr>
+            </a:tbl>
+          </a:graphicData>
+        </a:graphic>
+      </p:graphicFrame>
       <p:sp>
         <p:nvSpPr>
           <p:cNvPr id="25" name="Slide Number Placeholder 0"/>
@@ -3472,456 +3828,932 @@
                   <a:schemeClr val="tx1"/>
                 </a:solidFill>
               </a:rPr>
-              <a:t>Tech stack dan alasannya</a:t>
+              <a:t>Kenapa stack ini, dan apa alternatifnya</a:t>
             </a:r>
             <a:endParaRPr lang="en-US" sz="3200" dirty="0"/>
           </a:p>
         </p:txBody>
       </p:sp>
-      <p:sp>
-        <p:nvSpPr>
-          <p:cNvPr id="5" name="card"/>
-          <p:cNvSpPr/>
-          <p:nvPr/>
-        </p:nvSpPr>
-        <p:spPr>
-          <a:xfrm>
-            <a:off x="548640" y="1691640"/>
-            <a:ext cx="2606040" cy="2926080"/>
-          </a:xfrm>
-          <a:prstGeom prst="roundRect">
-            <a:avLst>
-              <a:gd name="adj" fmla="val 4211"/>
-            </a:avLst>
-          </a:prstGeom>
-          <a:solidFill>
-            <a:schemeClr val="accent1"/>
-          </a:solidFill>
-          <a:ln w="12700">
-            <a:solidFill>
-              <a:schemeClr val="accent1"/>
-            </a:solidFill>
-            <a:prstDash val="solid"/>
-          </a:ln>
-        </p:spPr>
-      </p:sp>
-      <p:sp>
-        <p:nvSpPr>
-          <p:cNvPr id="6" name="Text 3"/>
-          <p:cNvSpPr txBox="1"/>
-          <p:nvPr/>
-        </p:nvSpPr>
-        <p:spPr>
-          <a:xfrm>
-            <a:off x="822960" y="1965960"/>
-            <a:ext cx="2103120" cy="548640"/>
-          </a:xfrm>
-          <a:prstGeom prst="rect">
-            <a:avLst/>
-          </a:prstGeom>
-          <a:noFill/>
-          <a:ln/>
-        </p:spPr>
-        <p:txBody>
-          <a:bodyPr wrap="square" lIns="0" tIns="0" rIns="0" bIns="0" rtlCol="0" anchor="ctr"/>
-          <a:lstStyle/>
-          <a:p>
-            <a:pPr indent="0" marL="0">
-              <a:buNone/>
-            </a:pPr>
-            <a:r>
-              <a:rPr lang="en-US" sz="2200" b="1" dirty="0">
-                <a:solidFill>
-                  <a:schemeClr val="bg1"/>
-                </a:solidFill>
-                <a:latin typeface="+mj-lt" pitchFamily="34" charset="0"/>
-                <a:ea typeface="+mj-lt" pitchFamily="34" charset="-122"/>
-                <a:cs typeface="+mj-lt" pitchFamily="34" charset="-120"/>
-              </a:rPr>
-              <a:t>Laravel 10</a:t>
-            </a:r>
-            <a:endParaRPr lang="en-US" sz="2200" dirty="0"/>
-          </a:p>
-        </p:txBody>
-      </p:sp>
-      <p:sp>
-        <p:nvSpPr>
-          <p:cNvPr id="7" name="Text 4"/>
-          <p:cNvSpPr txBox="1"/>
-          <p:nvPr/>
-        </p:nvSpPr>
-        <p:spPr>
-          <a:xfrm>
-            <a:off x="822960" y="2697480"/>
-            <a:ext cx="2103120" cy="1737360"/>
-          </a:xfrm>
-          <a:prstGeom prst="rect">
-            <a:avLst/>
-          </a:prstGeom>
-          <a:noFill/>
-          <a:ln/>
-        </p:spPr>
-        <p:txBody>
-          <a:bodyPr wrap="square" lIns="0" tIns="0" rIns="0" bIns="0" rtlCol="0" anchor="t"/>
-          <a:lstStyle/>
-          <a:p>
-            <a:pPr indent="0" marL="0">
-              <a:buNone/>
-            </a:pPr>
-            <a:r>
-              <a:rPr lang="en-US" sz="1500" dirty="0">
-                <a:solidFill>
-                  <a:schemeClr val="bg1"/>
-                </a:solidFill>
-              </a:rPr>
-              <a:t>Dashboard admin: form, validasi, CRUD. Bagian yang saya kerjakan.</a:t>
-            </a:r>
-            <a:endParaRPr lang="en-US" sz="1500" dirty="0"/>
-          </a:p>
-        </p:txBody>
-      </p:sp>
-      <p:sp>
-        <p:nvSpPr>
-          <p:cNvPr id="8" name="card"/>
-          <p:cNvSpPr/>
-          <p:nvPr/>
-        </p:nvSpPr>
-        <p:spPr>
-          <a:xfrm>
-            <a:off x="3383280" y="1691640"/>
-            <a:ext cx="2606040" cy="2926080"/>
-          </a:xfrm>
-          <a:prstGeom prst="roundRect">
-            <a:avLst>
-              <a:gd name="adj" fmla="val 4211"/>
-            </a:avLst>
-          </a:prstGeom>
-          <a:solidFill>
-            <a:schemeClr val="tx2"/>
-          </a:solidFill>
-          <a:ln w="12700">
-            <a:solidFill>
-              <a:schemeClr val="tx2"/>
-            </a:solidFill>
-            <a:prstDash val="solid"/>
-          </a:ln>
-        </p:spPr>
-      </p:sp>
-      <p:sp>
-        <p:nvSpPr>
-          <p:cNvPr id="9" name="Text 6"/>
-          <p:cNvSpPr txBox="1"/>
-          <p:nvPr/>
-        </p:nvSpPr>
-        <p:spPr>
-          <a:xfrm>
-            <a:off x="3657600" y="1965960"/>
-            <a:ext cx="2103120" cy="548640"/>
-          </a:xfrm>
-          <a:prstGeom prst="rect">
-            <a:avLst/>
-          </a:prstGeom>
-          <a:noFill/>
-          <a:ln/>
-        </p:spPr>
-        <p:txBody>
-          <a:bodyPr wrap="square" lIns="0" tIns="0" rIns="0" bIns="0" rtlCol="0" anchor="ctr"/>
-          <a:lstStyle/>
-          <a:p>
-            <a:pPr indent="0" marL="0">
-              <a:buNone/>
-            </a:pPr>
-            <a:r>
-              <a:rPr lang="en-US" sz="2200" b="1" dirty="0">
-                <a:solidFill>
-                  <a:schemeClr val="bg1"/>
-                </a:solidFill>
-                <a:latin typeface="+mj-lt" pitchFamily="34" charset="0"/>
-                <a:ea typeface="+mj-lt" pitchFamily="34" charset="-122"/>
-                <a:cs typeface="+mj-lt" pitchFamily="34" charset="-120"/>
-              </a:rPr>
-              <a:t>PostgreSQL</a:t>
-            </a:r>
-            <a:endParaRPr lang="en-US" sz="2200" dirty="0"/>
-          </a:p>
-        </p:txBody>
-      </p:sp>
-      <p:sp>
-        <p:nvSpPr>
-          <p:cNvPr id="10" name="Text 7"/>
-          <p:cNvSpPr txBox="1"/>
-          <p:nvPr/>
-        </p:nvSpPr>
-        <p:spPr>
-          <a:xfrm>
-            <a:off x="3657600" y="2697480"/>
-            <a:ext cx="2103120" cy="1737360"/>
-          </a:xfrm>
-          <a:prstGeom prst="rect">
-            <a:avLst/>
-          </a:prstGeom>
-          <a:noFill/>
-          <a:ln/>
-        </p:spPr>
-        <p:txBody>
-          <a:bodyPr wrap="square" lIns="0" tIns="0" rIns="0" bIns="0" rtlCol="0" anchor="t"/>
-          <a:lstStyle/>
-          <a:p>
-            <a:pPr indent="0" marL="0">
-              <a:buNone/>
-            </a:pPr>
-            <a:r>
-              <a:rPr lang="en-US" sz="1500" dirty="0">
-                <a:solidFill>
-                  <a:schemeClr val="bg1"/>
-                </a:solidFill>
-              </a:rPr>
-              <a:t>Satu database untuk API dan dashboard, dengan transaksi dan kunci baris.</a:t>
-            </a:r>
-            <a:endParaRPr lang="en-US" sz="1500" dirty="0"/>
-          </a:p>
-        </p:txBody>
-      </p:sp>
-      <p:sp>
-        <p:nvSpPr>
-          <p:cNvPr id="11" name="card"/>
-          <p:cNvSpPr/>
-          <p:nvPr/>
-        </p:nvSpPr>
-        <p:spPr>
-          <a:xfrm>
-            <a:off x="6217920" y="1691640"/>
-            <a:ext cx="2606040" cy="2926080"/>
-          </a:xfrm>
-          <a:prstGeom prst="roundRect">
-            <a:avLst>
-              <a:gd name="adj" fmla="val 4211"/>
-            </a:avLst>
-          </a:prstGeom>
-          <a:solidFill>
-            <a:schemeClr val="bg2"/>
-          </a:solidFill>
-          <a:ln w="12700">
-            <a:solidFill>
-              <a:schemeClr val="bg2"/>
-            </a:solidFill>
-            <a:prstDash val="solid"/>
-          </a:ln>
-        </p:spPr>
-      </p:sp>
-      <p:sp>
-        <p:nvSpPr>
-          <p:cNvPr id="12" name="Text 9"/>
-          <p:cNvSpPr txBox="1"/>
-          <p:nvPr/>
-        </p:nvSpPr>
-        <p:spPr>
-          <a:xfrm>
-            <a:off x="6492240" y="1965960"/>
-            <a:ext cx="2103120" cy="548640"/>
-          </a:xfrm>
-          <a:prstGeom prst="rect">
-            <a:avLst/>
-          </a:prstGeom>
-          <a:noFill/>
-          <a:ln/>
-        </p:spPr>
-        <p:txBody>
-          <a:bodyPr wrap="square" lIns="0" tIns="0" rIns="0" bIns="0" rtlCol="0" anchor="ctr"/>
-          <a:lstStyle/>
-          <a:p>
-            <a:pPr indent="0" marL="0">
-              <a:buNone/>
-            </a:pPr>
-            <a:r>
-              <a:rPr lang="en-US" sz="2200" b="1" dirty="0">
-                <a:solidFill>
-                  <a:schemeClr val="tx1"/>
-                </a:solidFill>
-                <a:latin typeface="+mj-lt" pitchFamily="34" charset="0"/>
-                <a:ea typeface="+mj-lt" pitchFamily="34" charset="-122"/>
-                <a:cs typeface="+mj-lt" pitchFamily="34" charset="-120"/>
-              </a:rPr>
-              <a:t>Go</a:t>
-            </a:r>
-            <a:endParaRPr lang="en-US" sz="2200" dirty="0"/>
-          </a:p>
-        </p:txBody>
-      </p:sp>
-      <p:sp>
-        <p:nvSpPr>
-          <p:cNvPr id="13" name="Text 10"/>
-          <p:cNvSpPr txBox="1"/>
-          <p:nvPr/>
-        </p:nvSpPr>
-        <p:spPr>
-          <a:xfrm>
-            <a:off x="6492240" y="2697480"/>
-            <a:ext cx="2103120" cy="1737360"/>
-          </a:xfrm>
-          <a:prstGeom prst="rect">
-            <a:avLst/>
-          </a:prstGeom>
-          <a:noFill/>
-          <a:ln/>
-        </p:spPr>
-        <p:txBody>
-          <a:bodyPr wrap="square" lIns="0" tIns="0" rIns="0" bIns="0" rtlCol="0" anchor="t"/>
-          <a:lstStyle/>
-          <a:p>
-            <a:pPr indent="0" marL="0">
-              <a:buNone/>
-            </a:pPr>
-            <a:r>
-              <a:rPr lang="en-US" sz="1500" dirty="0">
-                <a:solidFill>
-                  <a:schemeClr val="tx1"/>
-                </a:solidFill>
-              </a:rPr>
-              <a:t>API aplikasi: trafik pemutaran tinggi, latensi rendah.</a:t>
-            </a:r>
-            <a:endParaRPr lang="en-US" sz="1500" dirty="0"/>
-          </a:p>
-        </p:txBody>
-      </p:sp>
-      <p:sp>
-        <p:nvSpPr>
-          <p:cNvPr id="14" name="card"/>
-          <p:cNvSpPr/>
-          <p:nvPr/>
-        </p:nvSpPr>
-        <p:spPr>
-          <a:xfrm>
-            <a:off x="9052560" y="1691640"/>
-            <a:ext cx="2606040" cy="2926080"/>
-          </a:xfrm>
-          <a:prstGeom prst="roundRect">
-            <a:avLst>
-              <a:gd name="adj" fmla="val 4211"/>
-            </a:avLst>
-          </a:prstGeom>
-          <a:solidFill>
-            <a:schemeClr val="bg2"/>
-          </a:solidFill>
-          <a:ln w="12700">
-            <a:solidFill>
-              <a:schemeClr val="bg2"/>
-            </a:solidFill>
-            <a:prstDash val="solid"/>
-          </a:ln>
-        </p:spPr>
-      </p:sp>
-      <p:sp>
-        <p:nvSpPr>
-          <p:cNvPr id="15" name="Text 12"/>
-          <p:cNvSpPr txBox="1"/>
-          <p:nvPr/>
-        </p:nvSpPr>
-        <p:spPr>
-          <a:xfrm>
-            <a:off x="9326880" y="1965960"/>
-            <a:ext cx="2103120" cy="548640"/>
-          </a:xfrm>
-          <a:prstGeom prst="rect">
-            <a:avLst/>
-          </a:prstGeom>
-          <a:noFill/>
-          <a:ln/>
-        </p:spPr>
-        <p:txBody>
-          <a:bodyPr wrap="square" lIns="0" tIns="0" rIns="0" bIns="0" rtlCol="0" anchor="ctr"/>
-          <a:lstStyle/>
-          <a:p>
-            <a:pPr indent="0" marL="0">
-              <a:buNone/>
-            </a:pPr>
-            <a:r>
-              <a:rPr lang="en-US" sz="2200" b="1" dirty="0">
-                <a:solidFill>
-                  <a:schemeClr val="tx1"/>
-                </a:solidFill>
-                <a:latin typeface="+mj-lt" pitchFamily="34" charset="0"/>
-                <a:ea typeface="+mj-lt" pitchFamily="34" charset="-122"/>
-                <a:cs typeface="+mj-lt" pitchFamily="34" charset="-120"/>
-              </a:rPr>
-              <a:t>Vue.js</a:t>
-            </a:r>
-            <a:endParaRPr lang="en-US" sz="2200" dirty="0"/>
-          </a:p>
-        </p:txBody>
-      </p:sp>
-      <p:sp>
-        <p:nvSpPr>
-          <p:cNvPr id="16" name="Text 13"/>
-          <p:cNvSpPr txBox="1"/>
-          <p:nvPr/>
-        </p:nvSpPr>
-        <p:spPr>
-          <a:xfrm>
-            <a:off x="9326880" y="2697480"/>
-            <a:ext cx="2103120" cy="1737360"/>
-          </a:xfrm>
-          <a:prstGeom prst="rect">
-            <a:avLst/>
-          </a:prstGeom>
-          <a:noFill/>
-          <a:ln/>
-        </p:spPr>
-        <p:txBody>
-          <a:bodyPr wrap="square" lIns="0" tIns="0" rIns="0" bIns="0" rtlCol="0" anchor="t"/>
-          <a:lstStyle/>
-          <a:p>
-            <a:pPr indent="0" marL="0">
-              <a:buNone/>
-            </a:pPr>
-            <a:r>
-              <a:rPr lang="en-US" sz="1500" dirty="0">
-                <a:solidFill>
-                  <a:schemeClr val="tx1"/>
-                </a:solidFill>
-              </a:rPr>
-              <a:t>Aplikasi web penonton.</a:t>
-            </a:r>
-            <a:endParaRPr lang="en-US" sz="1500" dirty="0"/>
-          </a:p>
-        </p:txBody>
-      </p:sp>
-      <p:sp>
-        <p:nvSpPr>
-          <p:cNvPr id="17" name="Text 14"/>
-          <p:cNvSpPr txBox="1"/>
-          <p:nvPr/>
-        </p:nvSpPr>
-        <p:spPr>
-          <a:xfrm>
-            <a:off x="548640" y="4983480"/>
-            <a:ext cx="11064240" cy="731520"/>
-          </a:xfrm>
-          <a:prstGeom prst="rect">
-            <a:avLst/>
-          </a:prstGeom>
-          <a:noFill/>
-          <a:ln/>
-        </p:spPr>
-        <p:txBody>
-          <a:bodyPr wrap="square" lIns="0" tIns="0" rIns="0" bIns="0" rtlCol="0" anchor="t"/>
-          <a:lstStyle/>
-          <a:p>
-            <a:pPr indent="0" marL="0">
-              <a:buNone/>
-            </a:pPr>
-            <a:r>
-              <a:rPr lang="en-US" sz="1500" dirty="0">
-                <a:solidFill>
-                  <a:schemeClr val="accent4"/>
-                </a:solidFill>
-              </a:rPr>
-              <a:t>Demo: Laravel 10, Blade, Tailwind, Chart.js, dan PostgreSQL seperti produksi. Yang hijau adalah bagian saya.</a:t>
-            </a:r>
-            <a:endParaRPr lang="en-US" sz="1500" dirty="0"/>
-          </a:p>
-        </p:txBody>
-      </p:sp>
+      <p:graphicFrame>
+        <p:nvGraphicFramePr>
+          <p:cNvPr id="12" name="Table 0"/>
+          <p:cNvGraphicFramePr>
+            <a:graphicFrameLocks noGrp="1"/>
+          </p:cNvGraphicFramePr>
+          <p:nvPr>
+            <p:extLst>
+              <p:ext uri="{D42A27DB-BD31-4B8C-83A1-F6EECF244321}">
+                <p14:modId xmlns:p14="http://schemas.microsoft.com/office/powerpoint/2010/main" val="1579011935"/>
+              </p:ext>
+            </p:extLst>
+          </p:nvPr>
+        </p:nvGraphicFramePr>
+        <p:xfrm>
+          <a:off x="548640" y="1508760"/>
+          <a:ext cx="11064240" cy="914400"/>
+        </p:xfrm>
+        <a:graphic>
+          <a:graphicData uri="http://schemas.openxmlformats.org/drawingml/2006/table">
+            <a:tbl>
+              <a:tblPr/>
+              <a:tblGrid>
+                <a:gridCol w="2194560"/>
+                <a:gridCol w="4114800"/>
+                <a:gridCol w="4754880"/>
+              </a:tblGrid>
+              <a:tr h="0">
+                <a:tc>
+                  <a:txBody>
+                    <a:bodyPr/>
+                    <a:lstStyle/>
+                    <a:p>
+                      <a:pPr indent="0" marL="0">
+                        <a:buNone/>
+                      </a:pPr>
+                      <a:r>
+                        <a:rPr lang="en-US" sz="1500" b="1" dirty="0">
+                          <a:solidFill>
+                            <a:srgbClr val="1E9E57"/>
+                          </a:solidFill>
+                        </a:rPr>
+                        <a:t>Pilihan</a:t>
+                      </a:r>
+                      <a:endParaRPr lang="en-US" sz="1500" dirty="0"/>
+                    </a:p>
+                  </a:txBody>
+                  <a:tcPr marL="164592" marR="164592" marT="182880" marB="182880" anchor="t">
+                    <a:lnL w="9525" cap="flat" cmpd="sng" algn="ctr">
+                      <a:solidFill>
+                        <a:srgbClr val="D6E2DA"/>
+                      </a:solidFill>
+                      <a:prstDash val="solid"/>
+                      <a:round/>
+                      <a:headEnd type="none" w="med" len="med"/>
+                      <a:tailEnd type="none" w="med" len="med"/>
+                    </a:lnL>
+                    <a:lnR w="9525" cap="flat" cmpd="sng" algn="ctr">
+                      <a:solidFill>
+                        <a:srgbClr val="D6E2DA"/>
+                      </a:solidFill>
+                      <a:prstDash val="solid"/>
+                      <a:round/>
+                      <a:headEnd type="none" w="med" len="med"/>
+                      <a:tailEnd type="none" w="med" len="med"/>
+                    </a:lnR>
+                    <a:lnT w="9525" cap="flat" cmpd="sng" algn="ctr">
+                      <a:solidFill>
+                        <a:srgbClr val="D6E2DA"/>
+                      </a:solidFill>
+                      <a:prstDash val="solid"/>
+                      <a:round/>
+                      <a:headEnd type="none" w="med" len="med"/>
+                      <a:tailEnd type="none" w="med" len="med"/>
+                    </a:lnT>
+                    <a:lnB w="9525" cap="flat" cmpd="sng" algn="ctr">
+                      <a:solidFill>
+                        <a:srgbClr val="D6E2DA"/>
+                      </a:solidFill>
+                      <a:prstDash val="solid"/>
+                      <a:round/>
+                      <a:headEnd type="none" w="med" len="med"/>
+                      <a:tailEnd type="none" w="med" len="med"/>
+                    </a:lnB>
+                    <a:solidFill>
+                      <a:srgbClr val="EEF3EF"/>
+                    </a:solidFill>
+                  </a:tcPr>
+                </a:tc>
+                <a:tc>
+                  <a:txBody>
+                    <a:bodyPr/>
+                    <a:lstStyle/>
+                    <a:p>
+                      <a:pPr indent="0" marL="0">
+                        <a:buNone/>
+                      </a:pPr>
+                      <a:r>
+                        <a:rPr lang="en-US" sz="1500" b="1" dirty="0">
+                          <a:solidFill>
+                            <a:srgbClr val="1E9E57"/>
+                          </a:solidFill>
+                        </a:rPr>
+                        <a:t>Kenapa</a:t>
+                      </a:r>
+                      <a:endParaRPr lang="en-US" sz="1500" dirty="0"/>
+                    </a:p>
+                  </a:txBody>
+                  <a:tcPr marL="164592" marR="164592" marT="182880" marB="182880" anchor="t">
+                    <a:lnL w="9525" cap="flat" cmpd="sng" algn="ctr">
+                      <a:solidFill>
+                        <a:srgbClr val="D6E2DA"/>
+                      </a:solidFill>
+                      <a:prstDash val="solid"/>
+                      <a:round/>
+                      <a:headEnd type="none" w="med" len="med"/>
+                      <a:tailEnd type="none" w="med" len="med"/>
+                    </a:lnL>
+                    <a:lnR w="9525" cap="flat" cmpd="sng" algn="ctr">
+                      <a:solidFill>
+                        <a:srgbClr val="D6E2DA"/>
+                      </a:solidFill>
+                      <a:prstDash val="solid"/>
+                      <a:round/>
+                      <a:headEnd type="none" w="med" len="med"/>
+                      <a:tailEnd type="none" w="med" len="med"/>
+                    </a:lnR>
+                    <a:lnT w="9525" cap="flat" cmpd="sng" algn="ctr">
+                      <a:solidFill>
+                        <a:srgbClr val="D6E2DA"/>
+                      </a:solidFill>
+                      <a:prstDash val="solid"/>
+                      <a:round/>
+                      <a:headEnd type="none" w="med" len="med"/>
+                      <a:tailEnd type="none" w="med" len="med"/>
+                    </a:lnT>
+                    <a:lnB w="9525" cap="flat" cmpd="sng" algn="ctr">
+                      <a:solidFill>
+                        <a:srgbClr val="D6E2DA"/>
+                      </a:solidFill>
+                      <a:prstDash val="solid"/>
+                      <a:round/>
+                      <a:headEnd type="none" w="med" len="med"/>
+                      <a:tailEnd type="none" w="med" len="med"/>
+                    </a:lnB>
+                    <a:solidFill>
+                      <a:srgbClr val="EEF3EF"/>
+                    </a:solidFill>
+                  </a:tcPr>
+                </a:tc>
+                <a:tc>
+                  <a:txBody>
+                    <a:bodyPr/>
+                    <a:lstStyle/>
+                    <a:p>
+                      <a:pPr indent="0" marL="0">
+                        <a:buNone/>
+                      </a:pPr>
+                      <a:r>
+                        <a:rPr lang="en-US" sz="1500" b="1" dirty="0">
+                          <a:solidFill>
+                            <a:srgbClr val="1E9E57"/>
+                          </a:solidFill>
+                        </a:rPr>
+                        <a:t>Alternatif yang saya pertimbangkan</a:t>
+                      </a:r>
+                      <a:endParaRPr lang="en-US" sz="1500" dirty="0"/>
+                    </a:p>
+                  </a:txBody>
+                  <a:tcPr marL="164592" marR="164592" marT="182880" marB="182880" anchor="t">
+                    <a:lnL w="9525" cap="flat" cmpd="sng" algn="ctr">
+                      <a:solidFill>
+                        <a:srgbClr val="D6E2DA"/>
+                      </a:solidFill>
+                      <a:prstDash val="solid"/>
+                      <a:round/>
+                      <a:headEnd type="none" w="med" len="med"/>
+                      <a:tailEnd type="none" w="med" len="med"/>
+                    </a:lnL>
+                    <a:lnR w="9525" cap="flat" cmpd="sng" algn="ctr">
+                      <a:solidFill>
+                        <a:srgbClr val="D6E2DA"/>
+                      </a:solidFill>
+                      <a:prstDash val="solid"/>
+                      <a:round/>
+                      <a:headEnd type="none" w="med" len="med"/>
+                      <a:tailEnd type="none" w="med" len="med"/>
+                    </a:lnR>
+                    <a:lnT w="9525" cap="flat" cmpd="sng" algn="ctr">
+                      <a:solidFill>
+                        <a:srgbClr val="D6E2DA"/>
+                      </a:solidFill>
+                      <a:prstDash val="solid"/>
+                      <a:round/>
+                      <a:headEnd type="none" w="med" len="med"/>
+                      <a:tailEnd type="none" w="med" len="med"/>
+                    </a:lnT>
+                    <a:lnB w="9525" cap="flat" cmpd="sng" algn="ctr">
+                      <a:solidFill>
+                        <a:srgbClr val="D6E2DA"/>
+                      </a:solidFill>
+                      <a:prstDash val="solid"/>
+                      <a:round/>
+                      <a:headEnd type="none" w="med" len="med"/>
+                      <a:tailEnd type="none" w="med" len="med"/>
+                    </a:lnB>
+                    <a:solidFill>
+                      <a:srgbClr val="EEF3EF"/>
+                    </a:solidFill>
+                  </a:tcPr>
+                </a:tc>
+              </a:tr>
+              <a:tr h="0">
+                <a:tc>
+                  <a:txBody>
+                    <a:bodyPr/>
+                    <a:lstStyle/>
+                    <a:p>
+                      <a:pPr indent="0" marL="0">
+                        <a:buNone/>
+                      </a:pPr>
+                      <a:r>
+                        <a:rPr lang="en-US" sz="1700" b="1" dirty="0">
+                          <a:solidFill>
+                            <a:srgbClr val="15211B"/>
+                          </a:solidFill>
+                        </a:rPr>
+                        <a:t>Laravel 10</a:t>
+                      </a:r>
+                      <a:endParaRPr lang="en-US" sz="1700" dirty="0"/>
+                    </a:p>
+                  </a:txBody>
+                  <a:tcPr marL="164592" marR="164592" marT="182880" marB="182880" anchor="t">
+                    <a:lnL w="9525" cap="flat" cmpd="sng" algn="ctr">
+                      <a:solidFill>
+                        <a:srgbClr val="D6E2DA"/>
+                      </a:solidFill>
+                      <a:prstDash val="solid"/>
+                      <a:round/>
+                      <a:headEnd type="none" w="med" len="med"/>
+                      <a:tailEnd type="none" w="med" len="med"/>
+                    </a:lnL>
+                    <a:lnR w="9525" cap="flat" cmpd="sng" algn="ctr">
+                      <a:solidFill>
+                        <a:srgbClr val="D6E2DA"/>
+                      </a:solidFill>
+                      <a:prstDash val="solid"/>
+                      <a:round/>
+                      <a:headEnd type="none" w="med" len="med"/>
+                      <a:tailEnd type="none" w="med" len="med"/>
+                    </a:lnR>
+                    <a:lnT w="9525" cap="flat" cmpd="sng" algn="ctr">
+                      <a:solidFill>
+                        <a:srgbClr val="D6E2DA"/>
+                      </a:solidFill>
+                      <a:prstDash val="solid"/>
+                      <a:round/>
+                      <a:headEnd type="none" w="med" len="med"/>
+                      <a:tailEnd type="none" w="med" len="med"/>
+                    </a:lnT>
+                    <a:lnB w="9525" cap="flat" cmpd="sng" algn="ctr">
+                      <a:solidFill>
+                        <a:srgbClr val="D6E2DA"/>
+                      </a:solidFill>
+                      <a:prstDash val="solid"/>
+                      <a:round/>
+                      <a:headEnd type="none" w="med" len="med"/>
+                      <a:tailEnd type="none" w="med" len="med"/>
+                    </a:lnB>
+                  </a:tcPr>
+                </a:tc>
+                <a:tc>
+                  <a:txBody>
+                    <a:bodyPr/>
+                    <a:lstStyle/>
+                    <a:p>
+                      <a:pPr indent="0" marL="0">
+                        <a:buNone/>
+                      </a:pPr>
+                      <a:r>
+                        <a:rPr lang="en-US" sz="1700" dirty="0">
+                          <a:solidFill>
+                            <a:srgbClr val="15211B"/>
+                          </a:solidFill>
+                        </a:rPr>
+                        <a:t>Dashboard: form, validasi, CRUD. Bagian saya</a:t>
+                      </a:r>
+                      <a:endParaRPr lang="en-US" sz="1700" dirty="0"/>
+                    </a:p>
+                  </a:txBody>
+                  <a:tcPr marL="164592" marR="164592" marT="182880" marB="182880" anchor="t">
+                    <a:lnL w="9525" cap="flat" cmpd="sng" algn="ctr">
+                      <a:solidFill>
+                        <a:srgbClr val="D6E2DA"/>
+                      </a:solidFill>
+                      <a:prstDash val="solid"/>
+                      <a:round/>
+                      <a:headEnd type="none" w="med" len="med"/>
+                      <a:tailEnd type="none" w="med" len="med"/>
+                    </a:lnL>
+                    <a:lnR w="9525" cap="flat" cmpd="sng" algn="ctr">
+                      <a:solidFill>
+                        <a:srgbClr val="D6E2DA"/>
+                      </a:solidFill>
+                      <a:prstDash val="solid"/>
+                      <a:round/>
+                      <a:headEnd type="none" w="med" len="med"/>
+                      <a:tailEnd type="none" w="med" len="med"/>
+                    </a:lnR>
+                    <a:lnT w="9525" cap="flat" cmpd="sng" algn="ctr">
+                      <a:solidFill>
+                        <a:srgbClr val="D6E2DA"/>
+                      </a:solidFill>
+                      <a:prstDash val="solid"/>
+                      <a:round/>
+                      <a:headEnd type="none" w="med" len="med"/>
+                      <a:tailEnd type="none" w="med" len="med"/>
+                    </a:lnT>
+                    <a:lnB w="9525" cap="flat" cmpd="sng" algn="ctr">
+                      <a:solidFill>
+                        <a:srgbClr val="D6E2DA"/>
+                      </a:solidFill>
+                      <a:prstDash val="solid"/>
+                      <a:round/>
+                      <a:headEnd type="none" w="med" len="med"/>
+                      <a:tailEnd type="none" w="med" len="med"/>
+                    </a:lnB>
+                  </a:tcPr>
+                </a:tc>
+                <a:tc>
+                  <a:txBody>
+                    <a:bodyPr/>
+                    <a:lstStyle/>
+                    <a:p>
+                      <a:pPr indent="0" marL="0">
+                        <a:buNone/>
+                      </a:pPr>
+                      <a:r>
+                        <a:rPr lang="en-US" sz="1700" dirty="0">
+                          <a:solidFill>
+                            <a:srgbClr val="15211B"/>
+                          </a:solidFill>
+                        </a:rPr>
+                        <a:t>Go juga untuk dashboard: satu bahasa, tapi CRUD admin jauh lebih lama dibuat</a:t>
+                      </a:r>
+                      <a:endParaRPr lang="en-US" sz="1700" dirty="0"/>
+                    </a:p>
+                  </a:txBody>
+                  <a:tcPr marL="164592" marR="164592" marT="182880" marB="182880" anchor="t">
+                    <a:lnL w="9525" cap="flat" cmpd="sng" algn="ctr">
+                      <a:solidFill>
+                        <a:srgbClr val="D6E2DA"/>
+                      </a:solidFill>
+                      <a:prstDash val="solid"/>
+                      <a:round/>
+                      <a:headEnd type="none" w="med" len="med"/>
+                      <a:tailEnd type="none" w="med" len="med"/>
+                    </a:lnL>
+                    <a:lnR w="9525" cap="flat" cmpd="sng" algn="ctr">
+                      <a:solidFill>
+                        <a:srgbClr val="D6E2DA"/>
+                      </a:solidFill>
+                      <a:prstDash val="solid"/>
+                      <a:round/>
+                      <a:headEnd type="none" w="med" len="med"/>
+                      <a:tailEnd type="none" w="med" len="med"/>
+                    </a:lnR>
+                    <a:lnT w="9525" cap="flat" cmpd="sng" algn="ctr">
+                      <a:solidFill>
+                        <a:srgbClr val="D6E2DA"/>
+                      </a:solidFill>
+                      <a:prstDash val="solid"/>
+                      <a:round/>
+                      <a:headEnd type="none" w="med" len="med"/>
+                      <a:tailEnd type="none" w="med" len="med"/>
+                    </a:lnT>
+                    <a:lnB w="9525" cap="flat" cmpd="sng" algn="ctr">
+                      <a:solidFill>
+                        <a:srgbClr val="D6E2DA"/>
+                      </a:solidFill>
+                      <a:prstDash val="solid"/>
+                      <a:round/>
+                      <a:headEnd type="none" w="med" len="med"/>
+                      <a:tailEnd type="none" w="med" len="med"/>
+                    </a:lnB>
+                  </a:tcPr>
+                </a:tc>
+              </a:tr>
+              <a:tr h="0">
+                <a:tc>
+                  <a:txBody>
+                    <a:bodyPr/>
+                    <a:lstStyle/>
+                    <a:p>
+                      <a:pPr indent="0" marL="0">
+                        <a:buNone/>
+                      </a:pPr>
+                      <a:r>
+                        <a:rPr lang="en-US" sz="1700" b="1" dirty="0">
+                          <a:solidFill>
+                            <a:srgbClr val="15211B"/>
+                          </a:solidFill>
+                        </a:rPr>
+                        <a:t>PostgreSQL</a:t>
+                      </a:r>
+                      <a:endParaRPr lang="en-US" sz="1700" dirty="0"/>
+                    </a:p>
+                  </a:txBody>
+                  <a:tcPr marL="164592" marR="164592" marT="182880" marB="182880" anchor="t">
+                    <a:lnL w="9525" cap="flat" cmpd="sng" algn="ctr">
+                      <a:solidFill>
+                        <a:srgbClr val="D6E2DA"/>
+                      </a:solidFill>
+                      <a:prstDash val="solid"/>
+                      <a:round/>
+                      <a:headEnd type="none" w="med" len="med"/>
+                      <a:tailEnd type="none" w="med" len="med"/>
+                    </a:lnL>
+                    <a:lnR w="9525" cap="flat" cmpd="sng" algn="ctr">
+                      <a:solidFill>
+                        <a:srgbClr val="D6E2DA"/>
+                      </a:solidFill>
+                      <a:prstDash val="solid"/>
+                      <a:round/>
+                      <a:headEnd type="none" w="med" len="med"/>
+                      <a:tailEnd type="none" w="med" len="med"/>
+                    </a:lnR>
+                    <a:lnT w="9525" cap="flat" cmpd="sng" algn="ctr">
+                      <a:solidFill>
+                        <a:srgbClr val="D6E2DA"/>
+                      </a:solidFill>
+                      <a:prstDash val="solid"/>
+                      <a:round/>
+                      <a:headEnd type="none" w="med" len="med"/>
+                      <a:tailEnd type="none" w="med" len="med"/>
+                    </a:lnT>
+                    <a:lnB w="9525" cap="flat" cmpd="sng" algn="ctr">
+                      <a:solidFill>
+                        <a:srgbClr val="D6E2DA"/>
+                      </a:solidFill>
+                      <a:prstDash val="solid"/>
+                      <a:round/>
+                      <a:headEnd type="none" w="med" len="med"/>
+                      <a:tailEnd type="none" w="med" len="med"/>
+                    </a:lnB>
+                  </a:tcPr>
+                </a:tc>
+                <a:tc>
+                  <a:txBody>
+                    <a:bodyPr/>
+                    <a:lstStyle/>
+                    <a:p>
+                      <a:pPr indent="0" marL="0">
+                        <a:buNone/>
+                      </a:pPr>
+                      <a:r>
+                        <a:rPr lang="en-US" sz="1700" dirty="0">
+                          <a:solidFill>
+                            <a:srgbClr val="15211B"/>
+                          </a:solidFill>
+                        </a:rPr>
+                        <a:t>Dipakai bersama API Go; transaksi dan row lock</a:t>
+                      </a:r>
+                      <a:endParaRPr lang="en-US" sz="1700" dirty="0"/>
+                    </a:p>
+                  </a:txBody>
+                  <a:tcPr marL="164592" marR="164592" marT="182880" marB="182880" anchor="t">
+                    <a:lnL w="9525" cap="flat" cmpd="sng" algn="ctr">
+                      <a:solidFill>
+                        <a:srgbClr val="D6E2DA"/>
+                      </a:solidFill>
+                      <a:prstDash val="solid"/>
+                      <a:round/>
+                      <a:headEnd type="none" w="med" len="med"/>
+                      <a:tailEnd type="none" w="med" len="med"/>
+                    </a:lnL>
+                    <a:lnR w="9525" cap="flat" cmpd="sng" algn="ctr">
+                      <a:solidFill>
+                        <a:srgbClr val="D6E2DA"/>
+                      </a:solidFill>
+                      <a:prstDash val="solid"/>
+                      <a:round/>
+                      <a:headEnd type="none" w="med" len="med"/>
+                      <a:tailEnd type="none" w="med" len="med"/>
+                    </a:lnR>
+                    <a:lnT w="9525" cap="flat" cmpd="sng" algn="ctr">
+                      <a:solidFill>
+                        <a:srgbClr val="D6E2DA"/>
+                      </a:solidFill>
+                      <a:prstDash val="solid"/>
+                      <a:round/>
+                      <a:headEnd type="none" w="med" len="med"/>
+                      <a:tailEnd type="none" w="med" len="med"/>
+                    </a:lnT>
+                    <a:lnB w="9525" cap="flat" cmpd="sng" algn="ctr">
+                      <a:solidFill>
+                        <a:srgbClr val="D6E2DA"/>
+                      </a:solidFill>
+                      <a:prstDash val="solid"/>
+                      <a:round/>
+                      <a:headEnd type="none" w="med" len="med"/>
+                      <a:tailEnd type="none" w="med" len="med"/>
+                    </a:lnB>
+                  </a:tcPr>
+                </a:tc>
+                <a:tc>
+                  <a:txBody>
+                    <a:bodyPr/>
+                    <a:lstStyle/>
+                    <a:p>
+                      <a:pPr indent="0" marL="0">
+                        <a:buNone/>
+                      </a:pPr>
+                      <a:r>
+                        <a:rPr lang="en-US" sz="1700" dirty="0">
+                          <a:solidFill>
+                            <a:srgbClr val="15211B"/>
+                          </a:solidFill>
+                        </a:rPr>
+                        <a:t>Database terpisah untuk dashboard: berarti sinkronisasi data dua arah</a:t>
+                      </a:r>
+                      <a:endParaRPr lang="en-US" sz="1700" dirty="0"/>
+                    </a:p>
+                  </a:txBody>
+                  <a:tcPr marL="164592" marR="164592" marT="182880" marB="182880" anchor="t">
+                    <a:lnL w="9525" cap="flat" cmpd="sng" algn="ctr">
+                      <a:solidFill>
+                        <a:srgbClr val="D6E2DA"/>
+                      </a:solidFill>
+                      <a:prstDash val="solid"/>
+                      <a:round/>
+                      <a:headEnd type="none" w="med" len="med"/>
+                      <a:tailEnd type="none" w="med" len="med"/>
+                    </a:lnL>
+                    <a:lnR w="9525" cap="flat" cmpd="sng" algn="ctr">
+                      <a:solidFill>
+                        <a:srgbClr val="D6E2DA"/>
+                      </a:solidFill>
+                      <a:prstDash val="solid"/>
+                      <a:round/>
+                      <a:headEnd type="none" w="med" len="med"/>
+                      <a:tailEnd type="none" w="med" len="med"/>
+                    </a:lnR>
+                    <a:lnT w="9525" cap="flat" cmpd="sng" algn="ctr">
+                      <a:solidFill>
+                        <a:srgbClr val="D6E2DA"/>
+                      </a:solidFill>
+                      <a:prstDash val="solid"/>
+                      <a:round/>
+                      <a:headEnd type="none" w="med" len="med"/>
+                      <a:tailEnd type="none" w="med" len="med"/>
+                    </a:lnT>
+                    <a:lnB w="9525" cap="flat" cmpd="sng" algn="ctr">
+                      <a:solidFill>
+                        <a:srgbClr val="D6E2DA"/>
+                      </a:solidFill>
+                      <a:prstDash val="solid"/>
+                      <a:round/>
+                      <a:headEnd type="none" w="med" len="med"/>
+                      <a:tailEnd type="none" w="med" len="med"/>
+                    </a:lnB>
+                  </a:tcPr>
+                </a:tc>
+              </a:tr>
+              <a:tr h="0">
+                <a:tc>
+                  <a:txBody>
+                    <a:bodyPr/>
+                    <a:lstStyle/>
+                    <a:p>
+                      <a:pPr indent="0" marL="0">
+                        <a:buNone/>
+                      </a:pPr>
+                      <a:r>
+                        <a:rPr lang="en-US" sz="1700" b="1" dirty="0">
+                          <a:solidFill>
+                            <a:srgbClr val="15211B"/>
+                          </a:solidFill>
+                        </a:rPr>
+                        <a:t>Go</a:t>
+                      </a:r>
+                      <a:endParaRPr lang="en-US" sz="1700" dirty="0"/>
+                    </a:p>
+                  </a:txBody>
+                  <a:tcPr marL="164592" marR="164592" marT="182880" marB="182880" anchor="t">
+                    <a:lnL w="9525" cap="flat" cmpd="sng" algn="ctr">
+                      <a:solidFill>
+                        <a:srgbClr val="D6E2DA"/>
+                      </a:solidFill>
+                      <a:prstDash val="solid"/>
+                      <a:round/>
+                      <a:headEnd type="none" w="med" len="med"/>
+                      <a:tailEnd type="none" w="med" len="med"/>
+                    </a:lnL>
+                    <a:lnR w="9525" cap="flat" cmpd="sng" algn="ctr">
+                      <a:solidFill>
+                        <a:srgbClr val="D6E2DA"/>
+                      </a:solidFill>
+                      <a:prstDash val="solid"/>
+                      <a:round/>
+                      <a:headEnd type="none" w="med" len="med"/>
+                      <a:tailEnd type="none" w="med" len="med"/>
+                    </a:lnR>
+                    <a:lnT w="9525" cap="flat" cmpd="sng" algn="ctr">
+                      <a:solidFill>
+                        <a:srgbClr val="D6E2DA"/>
+                      </a:solidFill>
+                      <a:prstDash val="solid"/>
+                      <a:round/>
+                      <a:headEnd type="none" w="med" len="med"/>
+                      <a:tailEnd type="none" w="med" len="med"/>
+                    </a:lnT>
+                    <a:lnB w="9525" cap="flat" cmpd="sng" algn="ctr">
+                      <a:solidFill>
+                        <a:srgbClr val="D6E2DA"/>
+                      </a:solidFill>
+                      <a:prstDash val="solid"/>
+                      <a:round/>
+                      <a:headEnd type="none" w="med" len="med"/>
+                      <a:tailEnd type="none" w="med" len="med"/>
+                    </a:lnB>
+                  </a:tcPr>
+                </a:tc>
+                <a:tc>
+                  <a:txBody>
+                    <a:bodyPr/>
+                    <a:lstStyle/>
+                    <a:p>
+                      <a:pPr indent="0" marL="0">
+                        <a:buNone/>
+                      </a:pPr>
+                      <a:r>
+                        <a:rPr lang="en-US" sz="1700" dirty="0">
+                          <a:solidFill>
+                            <a:srgbClr val="15211B"/>
+                          </a:solidFill>
+                        </a:rPr>
+                        <a:t>API aplikasi: trafik pemutaran tinggi</a:t>
+                      </a:r>
+                      <a:endParaRPr lang="en-US" sz="1700" dirty="0"/>
+                    </a:p>
+                  </a:txBody>
+                  <a:tcPr marL="164592" marR="164592" marT="182880" marB="182880" anchor="t">
+                    <a:lnL w="9525" cap="flat" cmpd="sng" algn="ctr">
+                      <a:solidFill>
+                        <a:srgbClr val="D6E2DA"/>
+                      </a:solidFill>
+                      <a:prstDash val="solid"/>
+                      <a:round/>
+                      <a:headEnd type="none" w="med" len="med"/>
+                      <a:tailEnd type="none" w="med" len="med"/>
+                    </a:lnL>
+                    <a:lnR w="9525" cap="flat" cmpd="sng" algn="ctr">
+                      <a:solidFill>
+                        <a:srgbClr val="D6E2DA"/>
+                      </a:solidFill>
+                      <a:prstDash val="solid"/>
+                      <a:round/>
+                      <a:headEnd type="none" w="med" len="med"/>
+                      <a:tailEnd type="none" w="med" len="med"/>
+                    </a:lnR>
+                    <a:lnT w="9525" cap="flat" cmpd="sng" algn="ctr">
+                      <a:solidFill>
+                        <a:srgbClr val="D6E2DA"/>
+                      </a:solidFill>
+                      <a:prstDash val="solid"/>
+                      <a:round/>
+                      <a:headEnd type="none" w="med" len="med"/>
+                      <a:tailEnd type="none" w="med" len="med"/>
+                    </a:lnT>
+                    <a:lnB w="9525" cap="flat" cmpd="sng" algn="ctr">
+                      <a:solidFill>
+                        <a:srgbClr val="D6E2DA"/>
+                      </a:solidFill>
+                      <a:prstDash val="solid"/>
+                      <a:round/>
+                      <a:headEnd type="none" w="med" len="med"/>
+                      <a:tailEnd type="none" w="med" len="med"/>
+                    </a:lnB>
+                  </a:tcPr>
+                </a:tc>
+                <a:tc>
+                  <a:txBody>
+                    <a:bodyPr/>
+                    <a:lstStyle/>
+                    <a:p>
+                      <a:pPr indent="0" marL="0">
+                        <a:buNone/>
+                      </a:pPr>
+                      <a:r>
+                        <a:rPr lang="en-US" sz="1700" dirty="0">
+                          <a:solidFill>
+                            <a:srgbClr val="15211B"/>
+                          </a:solidFill>
+                        </a:rPr>
+                        <a:t>Bukan bagian saya; sudah ada sebelum dashboard</a:t>
+                      </a:r>
+                      <a:endParaRPr lang="en-US" sz="1700" dirty="0"/>
+                    </a:p>
+                  </a:txBody>
+                  <a:tcPr marL="164592" marR="164592" marT="182880" marB="182880" anchor="t">
+                    <a:lnL w="9525" cap="flat" cmpd="sng" algn="ctr">
+                      <a:solidFill>
+                        <a:srgbClr val="D6E2DA"/>
+                      </a:solidFill>
+                      <a:prstDash val="solid"/>
+                      <a:round/>
+                      <a:headEnd type="none" w="med" len="med"/>
+                      <a:tailEnd type="none" w="med" len="med"/>
+                    </a:lnL>
+                    <a:lnR w="9525" cap="flat" cmpd="sng" algn="ctr">
+                      <a:solidFill>
+                        <a:srgbClr val="D6E2DA"/>
+                      </a:solidFill>
+                      <a:prstDash val="solid"/>
+                      <a:round/>
+                      <a:headEnd type="none" w="med" len="med"/>
+                      <a:tailEnd type="none" w="med" len="med"/>
+                    </a:lnR>
+                    <a:lnT w="9525" cap="flat" cmpd="sng" algn="ctr">
+                      <a:solidFill>
+                        <a:srgbClr val="D6E2DA"/>
+                      </a:solidFill>
+                      <a:prstDash val="solid"/>
+                      <a:round/>
+                      <a:headEnd type="none" w="med" len="med"/>
+                      <a:tailEnd type="none" w="med" len="med"/>
+                    </a:lnT>
+                    <a:lnB w="9525" cap="flat" cmpd="sng" algn="ctr">
+                      <a:solidFill>
+                        <a:srgbClr val="D6E2DA"/>
+                      </a:solidFill>
+                      <a:prstDash val="solid"/>
+                      <a:round/>
+                      <a:headEnd type="none" w="med" len="med"/>
+                      <a:tailEnd type="none" w="med" len="med"/>
+                    </a:lnB>
+                  </a:tcPr>
+                </a:tc>
+              </a:tr>
+              <a:tr h="0">
+                <a:tc>
+                  <a:txBody>
+                    <a:bodyPr/>
+                    <a:lstStyle/>
+                    <a:p>
+                      <a:pPr indent="0" marL="0">
+                        <a:buNone/>
+                      </a:pPr>
+                      <a:r>
+                        <a:rPr lang="en-US" sz="1700" b="1" dirty="0">
+                          <a:solidFill>
+                            <a:srgbClr val="15211B"/>
+                          </a:solidFill>
+                        </a:rPr>
+                        <a:t>Blade + Chart.js</a:t>
+                      </a:r>
+                      <a:endParaRPr lang="en-US" sz="1700" dirty="0"/>
+                    </a:p>
+                  </a:txBody>
+                  <a:tcPr marL="164592" marR="164592" marT="182880" marB="182880" anchor="t">
+                    <a:lnL w="9525" cap="flat" cmpd="sng" algn="ctr">
+                      <a:solidFill>
+                        <a:srgbClr val="D6E2DA"/>
+                      </a:solidFill>
+                      <a:prstDash val="solid"/>
+                      <a:round/>
+                      <a:headEnd type="none" w="med" len="med"/>
+                      <a:tailEnd type="none" w="med" len="med"/>
+                    </a:lnL>
+                    <a:lnR w="9525" cap="flat" cmpd="sng" algn="ctr">
+                      <a:solidFill>
+                        <a:srgbClr val="D6E2DA"/>
+                      </a:solidFill>
+                      <a:prstDash val="solid"/>
+                      <a:round/>
+                      <a:headEnd type="none" w="med" len="med"/>
+                      <a:tailEnd type="none" w="med" len="med"/>
+                    </a:lnR>
+                    <a:lnT w="9525" cap="flat" cmpd="sng" algn="ctr">
+                      <a:solidFill>
+                        <a:srgbClr val="D6E2DA"/>
+                      </a:solidFill>
+                      <a:prstDash val="solid"/>
+                      <a:round/>
+                      <a:headEnd type="none" w="med" len="med"/>
+                      <a:tailEnd type="none" w="med" len="med"/>
+                    </a:lnT>
+                    <a:lnB w="9525" cap="flat" cmpd="sng" algn="ctr">
+                      <a:solidFill>
+                        <a:srgbClr val="D6E2DA"/>
+                      </a:solidFill>
+                      <a:prstDash val="solid"/>
+                      <a:round/>
+                      <a:headEnd type="none" w="med" len="med"/>
+                      <a:tailEnd type="none" w="med" len="med"/>
+                    </a:lnB>
+                  </a:tcPr>
+                </a:tc>
+                <a:tc>
+                  <a:txBody>
+                    <a:bodyPr/>
+                    <a:lstStyle/>
+                    <a:p>
+                      <a:pPr indent="0" marL="0">
+                        <a:buNone/>
+                      </a:pPr>
+                      <a:r>
+                        <a:rPr lang="en-US" sz="1700" dirty="0">
+                          <a:solidFill>
+                            <a:srgbClr val="15211B"/>
+                          </a:solidFill>
+                        </a:rPr>
+                        <a:t>Admin internal tidak perlu SPA; satu grafik cukup Chart.js</a:t>
+                      </a:r>
+                      <a:endParaRPr lang="en-US" sz="1700" dirty="0"/>
+                    </a:p>
+                  </a:txBody>
+                  <a:tcPr marL="164592" marR="164592" marT="182880" marB="182880" anchor="t">
+                    <a:lnL w="9525" cap="flat" cmpd="sng" algn="ctr">
+                      <a:solidFill>
+                        <a:srgbClr val="D6E2DA"/>
+                      </a:solidFill>
+                      <a:prstDash val="solid"/>
+                      <a:round/>
+                      <a:headEnd type="none" w="med" len="med"/>
+                      <a:tailEnd type="none" w="med" len="med"/>
+                    </a:lnL>
+                    <a:lnR w="9525" cap="flat" cmpd="sng" algn="ctr">
+                      <a:solidFill>
+                        <a:srgbClr val="D6E2DA"/>
+                      </a:solidFill>
+                      <a:prstDash val="solid"/>
+                      <a:round/>
+                      <a:headEnd type="none" w="med" len="med"/>
+                      <a:tailEnd type="none" w="med" len="med"/>
+                    </a:lnR>
+                    <a:lnT w="9525" cap="flat" cmpd="sng" algn="ctr">
+                      <a:solidFill>
+                        <a:srgbClr val="D6E2DA"/>
+                      </a:solidFill>
+                      <a:prstDash val="solid"/>
+                      <a:round/>
+                      <a:headEnd type="none" w="med" len="med"/>
+                      <a:tailEnd type="none" w="med" len="med"/>
+                    </a:lnT>
+                    <a:lnB w="9525" cap="flat" cmpd="sng" algn="ctr">
+                      <a:solidFill>
+                        <a:srgbClr val="D6E2DA"/>
+                      </a:solidFill>
+                      <a:prstDash val="solid"/>
+                      <a:round/>
+                      <a:headEnd type="none" w="med" len="med"/>
+                      <a:tailEnd type="none" w="med" len="med"/>
+                    </a:lnB>
+                  </a:tcPr>
+                </a:tc>
+                <a:tc>
+                  <a:txBody>
+                    <a:bodyPr/>
+                    <a:lstStyle/>
+                    <a:p>
+                      <a:pPr indent="0" marL="0">
+                        <a:buNone/>
+                      </a:pPr>
+                      <a:r>
+                        <a:rPr lang="en-US" sz="1700" dirty="0">
+                          <a:solidFill>
+                            <a:srgbClr val="15211B"/>
+                          </a:solidFill>
+                        </a:rPr>
+                        <a:t>Vue seperti web penonton: build dan state terpisah untuk halaman form</a:t>
+                      </a:r>
+                      <a:endParaRPr lang="en-US" sz="1700" dirty="0"/>
+                    </a:p>
+                  </a:txBody>
+                  <a:tcPr marL="164592" marR="164592" marT="182880" marB="182880" anchor="t">
+                    <a:lnL w="9525" cap="flat" cmpd="sng" algn="ctr">
+                      <a:solidFill>
+                        <a:srgbClr val="D6E2DA"/>
+                      </a:solidFill>
+                      <a:prstDash val="solid"/>
+                      <a:round/>
+                      <a:headEnd type="none" w="med" len="med"/>
+                      <a:tailEnd type="none" w="med" len="med"/>
+                    </a:lnL>
+                    <a:lnR w="9525" cap="flat" cmpd="sng" algn="ctr">
+                      <a:solidFill>
+                        <a:srgbClr val="D6E2DA"/>
+                      </a:solidFill>
+                      <a:prstDash val="solid"/>
+                      <a:round/>
+                      <a:headEnd type="none" w="med" len="med"/>
+                      <a:tailEnd type="none" w="med" len="med"/>
+                    </a:lnR>
+                    <a:lnT w="9525" cap="flat" cmpd="sng" algn="ctr">
+                      <a:solidFill>
+                        <a:srgbClr val="D6E2DA"/>
+                      </a:solidFill>
+                      <a:prstDash val="solid"/>
+                      <a:round/>
+                      <a:headEnd type="none" w="med" len="med"/>
+                      <a:tailEnd type="none" w="med" len="med"/>
+                    </a:lnT>
+                    <a:lnB w="9525" cap="flat" cmpd="sng" algn="ctr">
+                      <a:solidFill>
+                        <a:srgbClr val="D6E2DA"/>
+                      </a:solidFill>
+                      <a:prstDash val="solid"/>
+                      <a:round/>
+                      <a:headEnd type="none" w="med" len="med"/>
+                      <a:tailEnd type="none" w="med" len="med"/>
+                    </a:lnB>
+                  </a:tcPr>
+                </a:tc>
+              </a:tr>
+            </a:tbl>
+          </a:graphicData>
+        </a:graphic>
+      </p:graphicFrame>
       <p:sp>
         <p:nvSpPr>
           <p:cNvPr id="25" name="Slide Number Placeholder 0"/>
@@ -4063,7 +4895,7 @@
                   <a:schemeClr val="tx1"/>
                 </a:solidFill>
               </a:rPr>
-              <a:t>Menjaga kode tetap mudah dibaca</a:t>
+              <a:t>Perpanjangan dalam satu transaksi</a:t>
             </a:r>
             <a:endParaRPr lang="en-US" sz="3200" dirty="0"/>
           </a:p>
@@ -4688,7 +5520,7 @@
                   <a:schemeClr val="tx1"/>
                 </a:solidFill>
               </a:rPr>
-              <a:t>Aplikasi demo</a:t>
+              <a:t>Demo: pendapatan, lalu cek akses pengguna</a:t>
             </a:r>
             <a:endParaRPr lang="en-US" sz="3200" dirty="0"/>
           </a:p>
@@ -4969,477 +5801,638 @@
                   <a:schemeClr val="tx1"/>
                 </a:solidFill>
               </a:rPr>
-              <a:t>Yang akan saya perbaiki</a:t>
+              <a:t>Yang belum selesai</a:t>
             </a:r>
             <a:endParaRPr lang="en-US" sz="3200" dirty="0"/>
           </a:p>
         </p:txBody>
       </p:sp>
-      <p:pic>
-        <p:nvPicPr>
-          <p:cNvPr id="5" name="Image 0" descr="preencoded.png">    </p:cNvPr>
-          <p:cNvPicPr>
-            <a:picLocks noChangeAspect="1"/>
-          </p:cNvPicPr>
-          <p:nvPr/>
-        </p:nvPicPr>
-        <p:blipFill>
-          <a:blip r:embed="rId1"/>
-          <a:stretch>
-            <a:fillRect/>
-          </a:stretch>
-        </p:blipFill>
-        <p:spPr>
-          <a:xfrm>
-            <a:off x="548640" y="1801368"/>
-            <a:ext cx="411480" cy="411480"/>
-          </a:xfrm>
-          <a:prstGeom prst="rect">
-            <a:avLst/>
-          </a:prstGeom>
-        </p:spPr>
-      </p:pic>
-      <p:sp>
-        <p:nvSpPr>
-          <p:cNvPr id="6" name="Text 2"/>
-          <p:cNvSpPr txBox="1"/>
-          <p:nvPr/>
-        </p:nvSpPr>
-        <p:spPr>
-          <a:xfrm>
-            <a:off x="1234440" y="1645920"/>
-            <a:ext cx="3840480" cy="731520"/>
-          </a:xfrm>
-          <a:prstGeom prst="rect">
-            <a:avLst/>
-          </a:prstGeom>
-          <a:noFill/>
-          <a:ln/>
-        </p:spPr>
-        <p:txBody>
-          <a:bodyPr wrap="square" lIns="0" tIns="0" rIns="0" bIns="0" rtlCol="0" anchor="ctr"/>
-          <a:lstStyle/>
-          <a:p>
-            <a:pPr indent="0" marL="0">
-              <a:buNone/>
-            </a:pPr>
-            <a:r>
-              <a:rPr lang="en-US" sz="1800" b="1" dirty="0">
-                <a:solidFill>
-                  <a:schemeClr val="tx1"/>
-                </a:solidFill>
-                <a:latin typeface="+mj-lt" pitchFamily="34" charset="0"/>
-                <a:ea typeface="+mj-lt" pitchFamily="34" charset="-122"/>
-                <a:cs typeface="+mj-lt" pitchFamily="34" charset="-120"/>
-              </a:rPr>
-              <a:t>Pindah ke tabel pivot</a:t>
-            </a:r>
-            <a:endParaRPr lang="en-US" sz="1800" dirty="0"/>
-          </a:p>
-        </p:txBody>
-      </p:sp>
-      <p:sp>
-        <p:nvSpPr>
-          <p:cNvPr id="7" name="Text 3"/>
-          <p:cNvSpPr txBox="1"/>
-          <p:nvPr/>
-        </p:nvSpPr>
-        <p:spPr>
-          <a:xfrm>
-            <a:off x="5212080" y="1645920"/>
-            <a:ext cx="6400800" cy="731520"/>
-          </a:xfrm>
-          <a:prstGeom prst="rect">
-            <a:avLst/>
-          </a:prstGeom>
-          <a:noFill/>
-          <a:ln/>
-        </p:spPr>
-        <p:txBody>
-          <a:bodyPr wrap="square" lIns="0" tIns="0" rIns="0" bIns="0" rtlCol="0" anchor="ctr"/>
-          <a:lstStyle/>
-          <a:p>
-            <a:pPr indent="0" marL="0">
-              <a:buNone/>
-            </a:pPr>
-            <a:r>
-              <a:rPr lang="en-US" sz="1500" dirty="0">
-                <a:solidFill>
-                  <a:schemeClr val="accent4"/>
-                </a:solidFill>
-              </a:rPr>
-              <a:t>Ganti ID dipisah koma secara bertahap, tanpa downtime.</a:t>
-            </a:r>
-            <a:endParaRPr lang="en-US" sz="1500" dirty="0"/>
-          </a:p>
-        </p:txBody>
-      </p:sp>
-      <p:sp>
-        <p:nvSpPr>
-          <p:cNvPr id="8" name="Shape 4"/>
-          <p:cNvSpPr/>
-          <p:nvPr/>
-        </p:nvSpPr>
-        <p:spPr>
-          <a:xfrm>
-            <a:off x="548640" y="2560320"/>
-            <a:ext cx="11064240" cy="914"/>
-          </a:xfrm>
-          <a:prstGeom prst="line">
-            <a:avLst/>
-          </a:prstGeom>
-          <a:noFill/>
-          <a:ln w="9525">
-            <a:solidFill>
-              <a:schemeClr val="accent6"/>
-            </a:solidFill>
-            <a:prstDash val="solid"/>
-          </a:ln>
-        </p:spPr>
-      </p:sp>
-      <p:pic>
-        <p:nvPicPr>
-          <p:cNvPr id="9" name="Image 1" descr="preencoded.png">    </p:cNvPr>
-          <p:cNvPicPr>
-            <a:picLocks noChangeAspect="1"/>
-          </p:cNvPicPr>
-          <p:nvPr/>
-        </p:nvPicPr>
-        <p:blipFill>
-          <a:blip r:embed="rId2"/>
-          <a:stretch>
-            <a:fillRect/>
-          </a:stretch>
-        </p:blipFill>
-        <p:spPr>
-          <a:xfrm>
-            <a:off x="548640" y="2898648"/>
-            <a:ext cx="411480" cy="411480"/>
-          </a:xfrm>
-          <a:prstGeom prst="rect">
-            <a:avLst/>
-          </a:prstGeom>
-        </p:spPr>
-      </p:pic>
-      <p:sp>
-        <p:nvSpPr>
-          <p:cNvPr id="10" name="Text 5"/>
-          <p:cNvSpPr txBox="1"/>
-          <p:nvPr/>
-        </p:nvSpPr>
-        <p:spPr>
-          <a:xfrm>
-            <a:off x="1234440" y="2743200"/>
-            <a:ext cx="3840480" cy="731520"/>
-          </a:xfrm>
-          <a:prstGeom prst="rect">
-            <a:avLst/>
-          </a:prstGeom>
-          <a:noFill/>
-          <a:ln/>
-        </p:spPr>
-        <p:txBody>
-          <a:bodyPr wrap="square" lIns="0" tIns="0" rIns="0" bIns="0" rtlCol="0" anchor="ctr"/>
-          <a:lstStyle/>
-          <a:p>
-            <a:pPr indent="0" marL="0">
-              <a:buNone/>
-            </a:pPr>
-            <a:r>
-              <a:rPr lang="en-US" sz="1800" b="1" dirty="0">
-                <a:solidFill>
-                  <a:schemeClr val="tx1"/>
-                </a:solidFill>
-                <a:latin typeface="+mj-lt" pitchFamily="34" charset="0"/>
-                <a:ea typeface="+mj-lt" pitchFamily="34" charset="-122"/>
-                <a:cs typeface="+mj-lt" pitchFamily="34" charset="-120"/>
-              </a:rPr>
-              <a:t>Satu kontrak aturan</a:t>
-            </a:r>
-            <a:endParaRPr lang="en-US" sz="1800" dirty="0"/>
-          </a:p>
-        </p:txBody>
-      </p:sp>
-      <p:sp>
-        <p:nvSpPr>
-          <p:cNvPr id="11" name="Text 6"/>
-          <p:cNvSpPr txBox="1"/>
-          <p:nvPr/>
-        </p:nvSpPr>
-        <p:spPr>
-          <a:xfrm>
-            <a:off x="5212080" y="2743200"/>
-            <a:ext cx="6400800" cy="731520"/>
-          </a:xfrm>
-          <a:prstGeom prst="rect">
-            <a:avLst/>
-          </a:prstGeom>
-          <a:noFill/>
-          <a:ln/>
-        </p:spPr>
-        <p:txBody>
-          <a:bodyPr wrap="square" lIns="0" tIns="0" rIns="0" bIns="0" rtlCol="0" anchor="ctr"/>
-          <a:lstStyle/>
-          <a:p>
-            <a:pPr indent="0" marL="0">
-              <a:buNone/>
-            </a:pPr>
-            <a:r>
-              <a:rPr lang="en-US" sz="1500" dirty="0">
-                <a:solidFill>
-                  <a:schemeClr val="accent4"/>
-                </a:solidFill>
-              </a:rPr>
-              <a:t>Aturan akses ada di Go dan Laravel; satu set kasus uji bersama menjaga keduanya sama.</a:t>
-            </a:r>
-            <a:endParaRPr lang="en-US" sz="1500" dirty="0"/>
-          </a:p>
-        </p:txBody>
-      </p:sp>
-      <p:sp>
-        <p:nvSpPr>
-          <p:cNvPr id="12" name="Shape 7"/>
-          <p:cNvSpPr/>
-          <p:nvPr/>
-        </p:nvSpPr>
-        <p:spPr>
-          <a:xfrm>
-            <a:off x="548640" y="3657600"/>
-            <a:ext cx="11064240" cy="914"/>
-          </a:xfrm>
-          <a:prstGeom prst="line">
-            <a:avLst/>
-          </a:prstGeom>
-          <a:noFill/>
-          <a:ln w="9525">
-            <a:solidFill>
-              <a:schemeClr val="accent6"/>
-            </a:solidFill>
-            <a:prstDash val="solid"/>
-          </a:ln>
-        </p:spPr>
-      </p:sp>
-      <p:pic>
-        <p:nvPicPr>
-          <p:cNvPr id="13" name="Image 2" descr="preencoded.png">    </p:cNvPr>
-          <p:cNvPicPr>
-            <a:picLocks noChangeAspect="1"/>
-          </p:cNvPicPr>
-          <p:nvPr/>
-        </p:nvPicPr>
-        <p:blipFill>
-          <a:blip r:embed="rId3"/>
-          <a:stretch>
-            <a:fillRect/>
-          </a:stretch>
-        </p:blipFill>
-        <p:spPr>
-          <a:xfrm>
-            <a:off x="548640" y="3995928"/>
-            <a:ext cx="411480" cy="411480"/>
-          </a:xfrm>
-          <a:prstGeom prst="rect">
-            <a:avLst/>
-          </a:prstGeom>
-        </p:spPr>
-      </p:pic>
-      <p:sp>
-        <p:nvSpPr>
-          <p:cNvPr id="14" name="Text 8"/>
-          <p:cNvSpPr txBox="1"/>
-          <p:nvPr/>
-        </p:nvSpPr>
-        <p:spPr>
-          <a:xfrm>
-            <a:off x="1234440" y="3840480"/>
-            <a:ext cx="3840480" cy="731520"/>
-          </a:xfrm>
-          <a:prstGeom prst="rect">
-            <a:avLst/>
-          </a:prstGeom>
-          <a:noFill/>
-          <a:ln/>
-        </p:spPr>
-        <p:txBody>
-          <a:bodyPr wrap="square" lIns="0" tIns="0" rIns="0" bIns="0" rtlCol="0" anchor="ctr"/>
-          <a:lstStyle/>
-          <a:p>
-            <a:pPr indent="0" marL="0">
-              <a:buNone/>
-            </a:pPr>
-            <a:r>
-              <a:rPr lang="en-US" sz="1800" b="1" dirty="0">
-                <a:solidFill>
-                  <a:schemeClr val="tx1"/>
-                </a:solidFill>
-                <a:latin typeface="+mj-lt" pitchFamily="34" charset="0"/>
-                <a:ea typeface="+mj-lt" pitchFamily="34" charset="-122"/>
-                <a:cs typeface="+mj-lt" pitchFamily="34" charset="-120"/>
-              </a:rPr>
-              <a:t>Riwayat tontonan besar</a:t>
-            </a:r>
-            <a:endParaRPr lang="en-US" sz="1800" dirty="0"/>
-          </a:p>
-        </p:txBody>
-      </p:sp>
-      <p:sp>
-        <p:nvSpPr>
-          <p:cNvPr id="15" name="Text 9"/>
-          <p:cNvSpPr txBox="1"/>
-          <p:nvPr/>
-        </p:nvSpPr>
-        <p:spPr>
-          <a:xfrm>
-            <a:off x="5212080" y="3840480"/>
-            <a:ext cx="6400800" cy="731520"/>
-          </a:xfrm>
-          <a:prstGeom prst="rect">
-            <a:avLst/>
-          </a:prstGeom>
-          <a:noFill/>
-          <a:ln/>
-        </p:spPr>
-        <p:txBody>
-          <a:bodyPr wrap="square" lIns="0" tIns="0" rIns="0" bIns="0" rtlCol="0" anchor="ctr"/>
-          <a:lstStyle/>
-          <a:p>
-            <a:pPr indent="0" marL="0">
-              <a:buNone/>
-            </a:pPr>
-            <a:r>
-              <a:rPr lang="en-US" sz="1500" dirty="0">
-                <a:solidFill>
-                  <a:schemeClr val="accent4"/>
-                </a:solidFill>
-              </a:rPr>
-              <a:t>Partisi watch_history per bulan, laporan dari tabel ringkasan harian.</a:t>
-            </a:r>
-            <a:endParaRPr lang="en-US" sz="1500" dirty="0"/>
-          </a:p>
-        </p:txBody>
-      </p:sp>
-      <p:sp>
-        <p:nvSpPr>
-          <p:cNvPr id="16" name="Shape 10"/>
-          <p:cNvSpPr/>
-          <p:nvPr/>
-        </p:nvSpPr>
-        <p:spPr>
-          <a:xfrm>
-            <a:off x="548640" y="4754880"/>
-            <a:ext cx="11064240" cy="914"/>
-          </a:xfrm>
-          <a:prstGeom prst="line">
-            <a:avLst/>
-          </a:prstGeom>
-          <a:noFill/>
-          <a:ln w="9525">
-            <a:solidFill>
-              <a:schemeClr val="accent6"/>
-            </a:solidFill>
-            <a:prstDash val="solid"/>
-          </a:ln>
-        </p:spPr>
-      </p:sp>
-      <p:pic>
-        <p:nvPicPr>
-          <p:cNvPr id="17" name="Image 3" descr="preencoded.png">    </p:cNvPr>
-          <p:cNvPicPr>
-            <a:picLocks noChangeAspect="1"/>
-          </p:cNvPicPr>
-          <p:nvPr/>
-        </p:nvPicPr>
-        <p:blipFill>
-          <a:blip r:embed="rId4"/>
-          <a:stretch>
-            <a:fillRect/>
-          </a:stretch>
-        </p:blipFill>
-        <p:spPr>
-          <a:xfrm>
-            <a:off x="548640" y="5093208"/>
-            <a:ext cx="411480" cy="411480"/>
-          </a:xfrm>
-          <a:prstGeom prst="rect">
-            <a:avLst/>
-          </a:prstGeom>
-        </p:spPr>
-      </p:pic>
-      <p:sp>
-        <p:nvSpPr>
-          <p:cNvPr id="18" name="Text 11"/>
-          <p:cNvSpPr txBox="1"/>
-          <p:nvPr/>
-        </p:nvSpPr>
-        <p:spPr>
-          <a:xfrm>
-            <a:off x="1234440" y="4937760"/>
-            <a:ext cx="3840480" cy="731520"/>
-          </a:xfrm>
-          <a:prstGeom prst="rect">
-            <a:avLst/>
-          </a:prstGeom>
-          <a:noFill/>
-          <a:ln/>
-        </p:spPr>
-        <p:txBody>
-          <a:bodyPr wrap="square" lIns="0" tIns="0" rIns="0" bIns="0" rtlCol="0" anchor="ctr"/>
-          <a:lstStyle/>
-          <a:p>
-            <a:pPr indent="0" marL="0">
-              <a:buNone/>
-            </a:pPr>
-            <a:r>
-              <a:rPr lang="en-US" sz="1800" b="1" dirty="0">
-                <a:solidFill>
-                  <a:schemeClr val="tx1"/>
-                </a:solidFill>
-                <a:latin typeface="+mj-lt" pitchFamily="34" charset="0"/>
-                <a:ea typeface="+mj-lt" pitchFamily="34" charset="-122"/>
-                <a:cs typeface="+mj-lt" pitchFamily="34" charset="-120"/>
-              </a:rPr>
-              <a:t>Constraint dan index</a:t>
-            </a:r>
-            <a:endParaRPr lang="en-US" sz="1800" dirty="0"/>
-          </a:p>
-        </p:txBody>
-      </p:sp>
-      <p:sp>
-        <p:nvSpPr>
-          <p:cNvPr id="19" name="Text 12"/>
-          <p:cNvSpPr txBox="1"/>
-          <p:nvPr/>
-        </p:nvSpPr>
-        <p:spPr>
-          <a:xfrm>
-            <a:off x="5212080" y="4937760"/>
-            <a:ext cx="6400800" cy="731520"/>
-          </a:xfrm>
-          <a:prstGeom prst="rect">
-            <a:avLst/>
-          </a:prstGeom>
-          <a:noFill/>
-          <a:ln/>
-        </p:spPr>
-        <p:txBody>
-          <a:bodyPr wrap="square" lIns="0" tIns="0" rIns="0" bIns="0" rtlCol="0" anchor="ctr"/>
-          <a:lstStyle/>
-          <a:p>
-            <a:pPr indent="0" marL="0">
-              <a:buNone/>
-            </a:pPr>
-            <a:r>
-              <a:rPr lang="en-US" sz="1500" dirty="0">
-                <a:solidFill>
-                  <a:schemeClr val="accent4"/>
-                </a:solidFill>
-              </a:rPr>
-              <a:t>Foreign key dan index di kolom cek akses dan laporan.</a:t>
-            </a:r>
-            <a:endParaRPr lang="en-US" sz="1500" dirty="0"/>
-          </a:p>
-        </p:txBody>
-      </p:sp>
+      <p:graphicFrame>
+        <p:nvGraphicFramePr>
+          <p:cNvPr id="15" name="Table 0"/>
+          <p:cNvGraphicFramePr>
+            <a:graphicFrameLocks noGrp="1"/>
+          </p:cNvGraphicFramePr>
+          <p:nvPr>
+            <p:extLst>
+              <p:ext uri="{D42A27DB-BD31-4B8C-83A1-F6EECF244321}">
+                <p14:modId xmlns:p14="http://schemas.microsoft.com/office/powerpoint/2010/main" val="1579011935"/>
+              </p:ext>
+            </p:extLst>
+          </p:nvPr>
+        </p:nvGraphicFramePr>
+        <p:xfrm>
+          <a:off x="548640" y="1508760"/>
+          <a:ext cx="11064240" cy="914400"/>
+        </p:xfrm>
+        <a:graphic>
+          <a:graphicData uri="http://schemas.openxmlformats.org/drawingml/2006/table">
+            <a:tbl>
+              <a:tblPr/>
+              <a:tblGrid>
+                <a:gridCol w="4023360"/>
+                <a:gridCol w="7040880"/>
+              </a:tblGrid>
+              <a:tr h="0">
+                <a:tc>
+                  <a:txBody>
+                    <a:bodyPr/>
+                    <a:lstStyle/>
+                    <a:p>
+                      <a:pPr indent="0" marL="0">
+                        <a:buNone/>
+                      </a:pPr>
+                      <a:r>
+                        <a:rPr lang="en-US" sz="1500" b="1" dirty="0">
+                          <a:solidFill>
+                            <a:srgbClr val="1E9E57"/>
+                          </a:solidFill>
+                        </a:rPr>
+                        <a:t>Yang belum</a:t>
+                      </a:r>
+                      <a:endParaRPr lang="en-US" sz="1500" dirty="0"/>
+                    </a:p>
+                  </a:txBody>
+                  <a:tcPr marL="164592" marR="164592" marT="182880" marB="182880" anchor="t">
+                    <a:lnL w="9525" cap="flat" cmpd="sng" algn="ctr">
+                      <a:solidFill>
+                        <a:srgbClr val="D6E2DA"/>
+                      </a:solidFill>
+                      <a:prstDash val="solid"/>
+                      <a:round/>
+                      <a:headEnd type="none" w="med" len="med"/>
+                      <a:tailEnd type="none" w="med" len="med"/>
+                    </a:lnL>
+                    <a:lnR w="9525" cap="flat" cmpd="sng" algn="ctr">
+                      <a:solidFill>
+                        <a:srgbClr val="D6E2DA"/>
+                      </a:solidFill>
+                      <a:prstDash val="solid"/>
+                      <a:round/>
+                      <a:headEnd type="none" w="med" len="med"/>
+                      <a:tailEnd type="none" w="med" len="med"/>
+                    </a:lnR>
+                    <a:lnT w="9525" cap="flat" cmpd="sng" algn="ctr">
+                      <a:solidFill>
+                        <a:srgbClr val="D6E2DA"/>
+                      </a:solidFill>
+                      <a:prstDash val="solid"/>
+                      <a:round/>
+                      <a:headEnd type="none" w="med" len="med"/>
+                      <a:tailEnd type="none" w="med" len="med"/>
+                    </a:lnT>
+                    <a:lnB w="9525" cap="flat" cmpd="sng" algn="ctr">
+                      <a:solidFill>
+                        <a:srgbClr val="D6E2DA"/>
+                      </a:solidFill>
+                      <a:prstDash val="solid"/>
+                      <a:round/>
+                      <a:headEnd type="none" w="med" len="med"/>
+                      <a:tailEnd type="none" w="med" len="med"/>
+                    </a:lnB>
+                    <a:solidFill>
+                      <a:srgbClr val="EEF3EF"/>
+                    </a:solidFill>
+                  </a:tcPr>
+                </a:tc>
+                <a:tc>
+                  <a:txBody>
+                    <a:bodyPr/>
+                    <a:lstStyle/>
+                    <a:p>
+                      <a:pPr indent="0" marL="0">
+                        <a:buNone/>
+                      </a:pPr>
+                      <a:r>
+                        <a:rPr lang="en-US" sz="1500" b="1" dirty="0">
+                          <a:solidFill>
+                            <a:srgbClr val="1E9E57"/>
+                          </a:solidFill>
+                        </a:rPr>
+                        <a:t>Langkah pertama</a:t>
+                      </a:r>
+                      <a:endParaRPr lang="en-US" sz="1500" dirty="0"/>
+                    </a:p>
+                  </a:txBody>
+                  <a:tcPr marL="164592" marR="164592" marT="182880" marB="182880" anchor="t">
+                    <a:lnL w="9525" cap="flat" cmpd="sng" algn="ctr">
+                      <a:solidFill>
+                        <a:srgbClr val="D6E2DA"/>
+                      </a:solidFill>
+                      <a:prstDash val="solid"/>
+                      <a:round/>
+                      <a:headEnd type="none" w="med" len="med"/>
+                      <a:tailEnd type="none" w="med" len="med"/>
+                    </a:lnL>
+                    <a:lnR w="9525" cap="flat" cmpd="sng" algn="ctr">
+                      <a:solidFill>
+                        <a:srgbClr val="D6E2DA"/>
+                      </a:solidFill>
+                      <a:prstDash val="solid"/>
+                      <a:round/>
+                      <a:headEnd type="none" w="med" len="med"/>
+                      <a:tailEnd type="none" w="med" len="med"/>
+                    </a:lnR>
+                    <a:lnT w="9525" cap="flat" cmpd="sng" algn="ctr">
+                      <a:solidFill>
+                        <a:srgbClr val="D6E2DA"/>
+                      </a:solidFill>
+                      <a:prstDash val="solid"/>
+                      <a:round/>
+                      <a:headEnd type="none" w="med" len="med"/>
+                      <a:tailEnd type="none" w="med" len="med"/>
+                    </a:lnT>
+                    <a:lnB w="9525" cap="flat" cmpd="sng" algn="ctr">
+                      <a:solidFill>
+                        <a:srgbClr val="D6E2DA"/>
+                      </a:solidFill>
+                      <a:prstDash val="solid"/>
+                      <a:round/>
+                      <a:headEnd type="none" w="med" len="med"/>
+                      <a:tailEnd type="none" w="med" len="med"/>
+                    </a:lnB>
+                    <a:solidFill>
+                      <a:srgbClr val="EEF3EF"/>
+                    </a:solidFill>
+                  </a:tcPr>
+                </a:tc>
+              </a:tr>
+              <a:tr h="0">
+                <a:tc>
+                  <a:txBody>
+                    <a:bodyPr/>
+                    <a:lstStyle/>
+                    <a:p>
+                      <a:pPr indent="0" marL="0">
+                        <a:buNone/>
+                      </a:pPr>
+                      <a:r>
+                        <a:rPr lang="en-US" sz="1700" b="1" dirty="0">
+                          <a:solidFill>
+                            <a:srgbClr val="15211B"/>
+                          </a:solidFill>
+                        </a:rPr>
+                        <a:t>Produksi masih menyimpan ID dipisah koma</a:t>
+                      </a:r>
+                      <a:endParaRPr lang="en-US" sz="1700" dirty="0"/>
+                    </a:p>
+                  </a:txBody>
+                  <a:tcPr marL="164592" marR="164592" marT="182880" marB="182880" anchor="t">
+                    <a:lnL w="9525" cap="flat" cmpd="sng" algn="ctr">
+                      <a:solidFill>
+                        <a:srgbClr val="D6E2DA"/>
+                      </a:solidFill>
+                      <a:prstDash val="solid"/>
+                      <a:round/>
+                      <a:headEnd type="none" w="med" len="med"/>
+                      <a:tailEnd type="none" w="med" len="med"/>
+                    </a:lnL>
+                    <a:lnR w="9525" cap="flat" cmpd="sng" algn="ctr">
+                      <a:solidFill>
+                        <a:srgbClr val="D6E2DA"/>
+                      </a:solidFill>
+                      <a:prstDash val="solid"/>
+                      <a:round/>
+                      <a:headEnd type="none" w="med" len="med"/>
+                      <a:tailEnd type="none" w="med" len="med"/>
+                    </a:lnR>
+                    <a:lnT w="9525" cap="flat" cmpd="sng" algn="ctr">
+                      <a:solidFill>
+                        <a:srgbClr val="D6E2DA"/>
+                      </a:solidFill>
+                      <a:prstDash val="solid"/>
+                      <a:round/>
+                      <a:headEnd type="none" w="med" len="med"/>
+                      <a:tailEnd type="none" w="med" len="med"/>
+                    </a:lnT>
+                    <a:lnB w="9525" cap="flat" cmpd="sng" algn="ctr">
+                      <a:solidFill>
+                        <a:srgbClr val="D6E2DA"/>
+                      </a:solidFill>
+                      <a:prstDash val="solid"/>
+                      <a:round/>
+                      <a:headEnd type="none" w="med" len="med"/>
+                      <a:tailEnd type="none" w="med" len="med"/>
+                    </a:lnB>
+                  </a:tcPr>
+                </a:tc>
+                <a:tc>
+                  <a:txBody>
+                    <a:bodyPr/>
+                    <a:lstStyle/>
+                    <a:p>
+                      <a:pPr indent="0" marL="0">
+                        <a:buNone/>
+                      </a:pPr>
+                      <a:r>
+                        <a:rPr lang="en-US" sz="1700" dirty="0">
+                          <a:solidFill>
+                            <a:srgbClr val="15211B"/>
+                          </a:solidFill>
+                        </a:rPr>
+                        <a:t>Buat tabel pivot, isi dari kolom lama, pindahkan pembaca satu per satu</a:t>
+                      </a:r>
+                      <a:endParaRPr lang="en-US" sz="1700" dirty="0"/>
+                    </a:p>
+                  </a:txBody>
+                  <a:tcPr marL="164592" marR="164592" marT="182880" marB="182880" anchor="t">
+                    <a:lnL w="9525" cap="flat" cmpd="sng" algn="ctr">
+                      <a:solidFill>
+                        <a:srgbClr val="D6E2DA"/>
+                      </a:solidFill>
+                      <a:prstDash val="solid"/>
+                      <a:round/>
+                      <a:headEnd type="none" w="med" len="med"/>
+                      <a:tailEnd type="none" w="med" len="med"/>
+                    </a:lnL>
+                    <a:lnR w="9525" cap="flat" cmpd="sng" algn="ctr">
+                      <a:solidFill>
+                        <a:srgbClr val="D6E2DA"/>
+                      </a:solidFill>
+                      <a:prstDash val="solid"/>
+                      <a:round/>
+                      <a:headEnd type="none" w="med" len="med"/>
+                      <a:tailEnd type="none" w="med" len="med"/>
+                    </a:lnR>
+                    <a:lnT w="9525" cap="flat" cmpd="sng" algn="ctr">
+                      <a:solidFill>
+                        <a:srgbClr val="D6E2DA"/>
+                      </a:solidFill>
+                      <a:prstDash val="solid"/>
+                      <a:round/>
+                      <a:headEnd type="none" w="med" len="med"/>
+                      <a:tailEnd type="none" w="med" len="med"/>
+                    </a:lnT>
+                    <a:lnB w="9525" cap="flat" cmpd="sng" algn="ctr">
+                      <a:solidFill>
+                        <a:srgbClr val="D6E2DA"/>
+                      </a:solidFill>
+                      <a:prstDash val="solid"/>
+                      <a:round/>
+                      <a:headEnd type="none" w="med" len="med"/>
+                      <a:tailEnd type="none" w="med" len="med"/>
+                    </a:lnB>
+                  </a:tcPr>
+                </a:tc>
+              </a:tr>
+              <a:tr h="0">
+                <a:tc>
+                  <a:txBody>
+                    <a:bodyPr/>
+                    <a:lstStyle/>
+                    <a:p>
+                      <a:pPr indent="0" marL="0">
+                        <a:buNone/>
+                      </a:pPr>
+                      <a:r>
+                        <a:rPr lang="en-US" sz="1700" b="1" dirty="0">
+                          <a:solidFill>
+                            <a:srgbClr val="15211B"/>
+                          </a:solidFill>
+                        </a:rPr>
+                        <a:t>Aturan akses ada di Go dan Laravel</a:t>
+                      </a:r>
+                      <a:endParaRPr lang="en-US" sz="1700" dirty="0"/>
+                    </a:p>
+                  </a:txBody>
+                  <a:tcPr marL="164592" marR="164592" marT="182880" marB="182880" anchor="t">
+                    <a:lnL w="9525" cap="flat" cmpd="sng" algn="ctr">
+                      <a:solidFill>
+                        <a:srgbClr val="D6E2DA"/>
+                      </a:solidFill>
+                      <a:prstDash val="solid"/>
+                      <a:round/>
+                      <a:headEnd type="none" w="med" len="med"/>
+                      <a:tailEnd type="none" w="med" len="med"/>
+                    </a:lnL>
+                    <a:lnR w="9525" cap="flat" cmpd="sng" algn="ctr">
+                      <a:solidFill>
+                        <a:srgbClr val="D6E2DA"/>
+                      </a:solidFill>
+                      <a:prstDash val="solid"/>
+                      <a:round/>
+                      <a:headEnd type="none" w="med" len="med"/>
+                      <a:tailEnd type="none" w="med" len="med"/>
+                    </a:lnR>
+                    <a:lnT w="9525" cap="flat" cmpd="sng" algn="ctr">
+                      <a:solidFill>
+                        <a:srgbClr val="D6E2DA"/>
+                      </a:solidFill>
+                      <a:prstDash val="solid"/>
+                      <a:round/>
+                      <a:headEnd type="none" w="med" len="med"/>
+                      <a:tailEnd type="none" w="med" len="med"/>
+                    </a:lnT>
+                    <a:lnB w="9525" cap="flat" cmpd="sng" algn="ctr">
+                      <a:solidFill>
+                        <a:srgbClr val="D6E2DA"/>
+                      </a:solidFill>
+                      <a:prstDash val="solid"/>
+                      <a:round/>
+                      <a:headEnd type="none" w="med" len="med"/>
+                      <a:tailEnd type="none" w="med" len="med"/>
+                    </a:lnB>
+                  </a:tcPr>
+                </a:tc>
+                <a:tc>
+                  <a:txBody>
+                    <a:bodyPr/>
+                    <a:lstStyle/>
+                    <a:p>
+                      <a:pPr indent="0" marL="0">
+                        <a:buNone/>
+                      </a:pPr>
+                      <a:r>
+                        <a:rPr lang="en-US" sz="1700" dirty="0">
+                          <a:solidFill>
+                            <a:srgbClr val="15211B"/>
+                          </a:solidFill>
+                        </a:rPr>
+                        <a:t>Satu set kasus uji bersama yang dijalankan kedua sisi</a:t>
+                      </a:r>
+                      <a:endParaRPr lang="en-US" sz="1700" dirty="0"/>
+                    </a:p>
+                  </a:txBody>
+                  <a:tcPr marL="164592" marR="164592" marT="182880" marB="182880" anchor="t">
+                    <a:lnL w="9525" cap="flat" cmpd="sng" algn="ctr">
+                      <a:solidFill>
+                        <a:srgbClr val="D6E2DA"/>
+                      </a:solidFill>
+                      <a:prstDash val="solid"/>
+                      <a:round/>
+                      <a:headEnd type="none" w="med" len="med"/>
+                      <a:tailEnd type="none" w="med" len="med"/>
+                    </a:lnL>
+                    <a:lnR w="9525" cap="flat" cmpd="sng" algn="ctr">
+                      <a:solidFill>
+                        <a:srgbClr val="D6E2DA"/>
+                      </a:solidFill>
+                      <a:prstDash val="solid"/>
+                      <a:round/>
+                      <a:headEnd type="none" w="med" len="med"/>
+                      <a:tailEnd type="none" w="med" len="med"/>
+                    </a:lnR>
+                    <a:lnT w="9525" cap="flat" cmpd="sng" algn="ctr">
+                      <a:solidFill>
+                        <a:srgbClr val="D6E2DA"/>
+                      </a:solidFill>
+                      <a:prstDash val="solid"/>
+                      <a:round/>
+                      <a:headEnd type="none" w="med" len="med"/>
+                      <a:tailEnd type="none" w="med" len="med"/>
+                    </a:lnT>
+                    <a:lnB w="9525" cap="flat" cmpd="sng" algn="ctr">
+                      <a:solidFill>
+                        <a:srgbClr val="D6E2DA"/>
+                      </a:solidFill>
+                      <a:prstDash val="solid"/>
+                      <a:round/>
+                      <a:headEnd type="none" w="med" len="med"/>
+                      <a:tailEnd type="none" w="med" len="med"/>
+                    </a:lnB>
+                  </a:tcPr>
+                </a:tc>
+              </a:tr>
+              <a:tr h="0">
+                <a:tc>
+                  <a:txBody>
+                    <a:bodyPr/>
+                    <a:lstStyle/>
+                    <a:p>
+                      <a:pPr indent="0" marL="0">
+                        <a:buNone/>
+                      </a:pPr>
+                      <a:r>
+                        <a:rPr lang="en-US" sz="1700" b="1" dirty="0">
+                          <a:solidFill>
+                            <a:srgbClr val="15211B"/>
+                          </a:solidFill>
+                        </a:rPr>
+                        <a:t>watch_history terus membesar</a:t>
+                      </a:r>
+                      <a:endParaRPr lang="en-US" sz="1700" dirty="0"/>
+                    </a:p>
+                  </a:txBody>
+                  <a:tcPr marL="164592" marR="164592" marT="182880" marB="182880" anchor="t">
+                    <a:lnL w="9525" cap="flat" cmpd="sng" algn="ctr">
+                      <a:solidFill>
+                        <a:srgbClr val="D6E2DA"/>
+                      </a:solidFill>
+                      <a:prstDash val="solid"/>
+                      <a:round/>
+                      <a:headEnd type="none" w="med" len="med"/>
+                      <a:tailEnd type="none" w="med" len="med"/>
+                    </a:lnL>
+                    <a:lnR w="9525" cap="flat" cmpd="sng" algn="ctr">
+                      <a:solidFill>
+                        <a:srgbClr val="D6E2DA"/>
+                      </a:solidFill>
+                      <a:prstDash val="solid"/>
+                      <a:round/>
+                      <a:headEnd type="none" w="med" len="med"/>
+                      <a:tailEnd type="none" w="med" len="med"/>
+                    </a:lnR>
+                    <a:lnT w="9525" cap="flat" cmpd="sng" algn="ctr">
+                      <a:solidFill>
+                        <a:srgbClr val="D6E2DA"/>
+                      </a:solidFill>
+                      <a:prstDash val="solid"/>
+                      <a:round/>
+                      <a:headEnd type="none" w="med" len="med"/>
+                      <a:tailEnd type="none" w="med" len="med"/>
+                    </a:lnT>
+                    <a:lnB w="9525" cap="flat" cmpd="sng" algn="ctr">
+                      <a:solidFill>
+                        <a:srgbClr val="D6E2DA"/>
+                      </a:solidFill>
+                      <a:prstDash val="solid"/>
+                      <a:round/>
+                      <a:headEnd type="none" w="med" len="med"/>
+                      <a:tailEnd type="none" w="med" len="med"/>
+                    </a:lnB>
+                  </a:tcPr>
+                </a:tc>
+                <a:tc>
+                  <a:txBody>
+                    <a:bodyPr/>
+                    <a:lstStyle/>
+                    <a:p>
+                      <a:pPr indent="0" marL="0">
+                        <a:buNone/>
+                      </a:pPr>
+                      <a:r>
+                        <a:rPr lang="en-US" sz="1700" dirty="0">
+                          <a:solidFill>
+                            <a:srgbClr val="15211B"/>
+                          </a:solidFill>
+                        </a:rPr>
+                        <a:t>Partisi per bulan; laporan dari tabel ringkasan harian</a:t>
+                      </a:r>
+                      <a:endParaRPr lang="en-US" sz="1700" dirty="0"/>
+                    </a:p>
+                  </a:txBody>
+                  <a:tcPr marL="164592" marR="164592" marT="182880" marB="182880" anchor="t">
+                    <a:lnL w="9525" cap="flat" cmpd="sng" algn="ctr">
+                      <a:solidFill>
+                        <a:srgbClr val="D6E2DA"/>
+                      </a:solidFill>
+                      <a:prstDash val="solid"/>
+                      <a:round/>
+                      <a:headEnd type="none" w="med" len="med"/>
+                      <a:tailEnd type="none" w="med" len="med"/>
+                    </a:lnL>
+                    <a:lnR w="9525" cap="flat" cmpd="sng" algn="ctr">
+                      <a:solidFill>
+                        <a:srgbClr val="D6E2DA"/>
+                      </a:solidFill>
+                      <a:prstDash val="solid"/>
+                      <a:round/>
+                      <a:headEnd type="none" w="med" len="med"/>
+                      <a:tailEnd type="none" w="med" len="med"/>
+                    </a:lnR>
+                    <a:lnT w="9525" cap="flat" cmpd="sng" algn="ctr">
+                      <a:solidFill>
+                        <a:srgbClr val="D6E2DA"/>
+                      </a:solidFill>
+                      <a:prstDash val="solid"/>
+                      <a:round/>
+                      <a:headEnd type="none" w="med" len="med"/>
+                      <a:tailEnd type="none" w="med" len="med"/>
+                    </a:lnT>
+                    <a:lnB w="9525" cap="flat" cmpd="sng" algn="ctr">
+                      <a:solidFill>
+                        <a:srgbClr val="D6E2DA"/>
+                      </a:solidFill>
+                      <a:prstDash val="solid"/>
+                      <a:round/>
+                      <a:headEnd type="none" w="med" len="med"/>
+                      <a:tailEnd type="none" w="med" len="med"/>
+                    </a:lnB>
+                  </a:tcPr>
+                </a:tc>
+              </a:tr>
+              <a:tr h="0">
+                <a:tc>
+                  <a:txBody>
+                    <a:bodyPr/>
+                    <a:lstStyle/>
+                    <a:p>
+                      <a:pPr indent="0" marL="0">
+                        <a:buNone/>
+                      </a:pPr>
+                      <a:r>
+                        <a:rPr lang="en-US" sz="1700" b="1" dirty="0">
+                          <a:solidFill>
+                            <a:srgbClr val="15211B"/>
+                          </a:solidFill>
+                        </a:rPr>
+                        <a:t>Produksi tanpa foreign key</a:t>
+                      </a:r>
+                      <a:endParaRPr lang="en-US" sz="1700" dirty="0"/>
+                    </a:p>
+                  </a:txBody>
+                  <a:tcPr marL="164592" marR="164592" marT="182880" marB="182880" anchor="t">
+                    <a:lnL w="9525" cap="flat" cmpd="sng" algn="ctr">
+                      <a:solidFill>
+                        <a:srgbClr val="D6E2DA"/>
+                      </a:solidFill>
+                      <a:prstDash val="solid"/>
+                      <a:round/>
+                      <a:headEnd type="none" w="med" len="med"/>
+                      <a:tailEnd type="none" w="med" len="med"/>
+                    </a:lnL>
+                    <a:lnR w="9525" cap="flat" cmpd="sng" algn="ctr">
+                      <a:solidFill>
+                        <a:srgbClr val="D6E2DA"/>
+                      </a:solidFill>
+                      <a:prstDash val="solid"/>
+                      <a:round/>
+                      <a:headEnd type="none" w="med" len="med"/>
+                      <a:tailEnd type="none" w="med" len="med"/>
+                    </a:lnR>
+                    <a:lnT w="9525" cap="flat" cmpd="sng" algn="ctr">
+                      <a:solidFill>
+                        <a:srgbClr val="D6E2DA"/>
+                      </a:solidFill>
+                      <a:prstDash val="solid"/>
+                      <a:round/>
+                      <a:headEnd type="none" w="med" len="med"/>
+                      <a:tailEnd type="none" w="med" len="med"/>
+                    </a:lnT>
+                    <a:lnB w="9525" cap="flat" cmpd="sng" algn="ctr">
+                      <a:solidFill>
+                        <a:srgbClr val="D6E2DA"/>
+                      </a:solidFill>
+                      <a:prstDash val="solid"/>
+                      <a:round/>
+                      <a:headEnd type="none" w="med" len="med"/>
+                      <a:tailEnd type="none" w="med" len="med"/>
+                    </a:lnB>
+                  </a:tcPr>
+                </a:tc>
+                <a:tc>
+                  <a:txBody>
+                    <a:bodyPr/>
+                    <a:lstStyle/>
+                    <a:p>
+                      <a:pPr indent="0" marL="0">
+                        <a:buNone/>
+                      </a:pPr>
+                      <a:r>
+                        <a:rPr lang="en-US" sz="1700" dirty="0">
+                          <a:solidFill>
+                            <a:srgbClr val="15211B"/>
+                          </a:solidFill>
+                        </a:rPr>
+                        <a:t>Foreign key dan index di kolom cek akses dan laporan</a:t>
+                      </a:r>
+                      <a:endParaRPr lang="en-US" sz="1700" dirty="0"/>
+                    </a:p>
+                  </a:txBody>
+                  <a:tcPr marL="164592" marR="164592" marT="182880" marB="182880" anchor="t">
+                    <a:lnL w="9525" cap="flat" cmpd="sng" algn="ctr">
+                      <a:solidFill>
+                        <a:srgbClr val="D6E2DA"/>
+                      </a:solidFill>
+                      <a:prstDash val="solid"/>
+                      <a:round/>
+                      <a:headEnd type="none" w="med" len="med"/>
+                      <a:tailEnd type="none" w="med" len="med"/>
+                    </a:lnL>
+                    <a:lnR w="9525" cap="flat" cmpd="sng" algn="ctr">
+                      <a:solidFill>
+                        <a:srgbClr val="D6E2DA"/>
+                      </a:solidFill>
+                      <a:prstDash val="solid"/>
+                      <a:round/>
+                      <a:headEnd type="none" w="med" len="med"/>
+                      <a:tailEnd type="none" w="med" len="med"/>
+                    </a:lnR>
+                    <a:lnT w="9525" cap="flat" cmpd="sng" algn="ctr">
+                      <a:solidFill>
+                        <a:srgbClr val="D6E2DA"/>
+                      </a:solidFill>
+                      <a:prstDash val="solid"/>
+                      <a:round/>
+                      <a:headEnd type="none" w="med" len="med"/>
+                      <a:tailEnd type="none" w="med" len="med"/>
+                    </a:lnT>
+                    <a:lnB w="9525" cap="flat" cmpd="sng" algn="ctr">
+                      <a:solidFill>
+                        <a:srgbClr val="D6E2DA"/>
+                      </a:solidFill>
+                      <a:prstDash val="solid"/>
+                      <a:round/>
+                      <a:headEnd type="none" w="med" len="med"/>
+                      <a:tailEnd type="none" w="med" len="med"/>
+                    </a:lnB>
+                  </a:tcPr>
+                </a:tc>
+              </a:tr>
+            </a:tbl>
+          </a:graphicData>
+        </a:graphic>
+      </p:graphicFrame>
       <p:sp>
         <p:nvSpPr>
           <p:cNvPr id="25" name="Slide Number Placeholder 0"/>
@@ -5542,7 +6535,7 @@
                   <a:schemeClr val="bg1"/>
                 </a:solidFill>
               </a:rPr>
-              <a:t>Coba sendiri</a:t>
+              <a:t>Link demo dan slide</a:t>
             </a:r>
             <a:endParaRPr lang="en-US" sz="6000" dirty="0"/>
           </a:p>

</xml_diff>

<commit_message>
Decks: fill in the document properties
</commit_message>
<xml_diff>
--- a/docs/Goflix-presentasi.pptx
+++ b/docs/Goflix-presentasi.pptx
@@ -123,12 +123,12 @@
   <p:extLst>
     <p:ext uri="{521415D9-36F7-43E2-AB2F-B90AF26B5E84}">
       <p14:sectionLst xmlns:p14="http://schemas.microsoft.com/office/powerpoint/2010/main">
-        <p14:section name="Pembuka" id="{e23f335f-0ca7-945a-6294-c218d6148139}">
+        <p14:section name="Pembuka" id="{1bfaa92b-65ab-608d-99c9-44e93316f31f}">
           <p14:sldIdLst>
             <p14:sldId id="256"/>
           </p14:sldIdLst>
         </p14:section>
-        <p14:section name="Produk" id="{64311dd8-5d45-14bb-c9c5-fac4ca8beeca}">
+        <p14:section name="Produk" id="{79060a01-8f69-a020-f10f-adc82eb3b214}">
           <p14:sldIdLst>
             <p14:sldId id="257"/>
             <p14:sldId id="258"/>
@@ -136,7 +136,7 @@
             <p14:sldId id="260"/>
           </p14:sldIdLst>
         </p14:section>
-        <p14:section name="Desain sistem" id="{edecd7bd-13f1-c9d2-2328-18f7d37f2350}">
+        <p14:section name="Desain sistem" id="{0db0d567-e009-37e7-8cda-cb55bdc81153}">
           <p14:sldIdLst>
             <p14:sldId id="261"/>
             <p14:sldId id="262"/>
@@ -145,21 +145,21 @@
             <p14:sldId id="265"/>
           </p14:sldIdLst>
         </p14:section>
-        <p14:section name="Aturan bisnis" id="{7a988e9c-5a0f-11d3-b6d9-ef076f6fc885}">
+        <p14:section name="Aturan bisnis" id="{c29f938d-3a42-0c32-c83b-a5f7bcd3bb0f}">
           <p14:sldIdLst>
             <p14:sldId id="266"/>
             <p14:sldId id="267"/>
             <p14:sldId id="268"/>
           </p14:sldIdLst>
         </p14:section>
-        <p14:section name="Kode" id="{53ce958a-7675-1071-5bb0-c5a750007f92}">
+        <p14:section name="Kode" id="{ee79b8a7-558d-fca2-3caa-916c79e9cb82}">
           <p14:sldIdLst>
             <p14:sldId id="269"/>
             <p14:sldId id="270"/>
             <p14:sldId id="271"/>
           </p14:sldIdLst>
         </p14:section>
-        <p14:section name="Penutup" id="{9a838467-ce7b-3e86-994e-61f934a398b1}">
+        <p14:section name="Penutup" id="{18b51f55-a4bc-748e-0c5a-ee15e1ca0ff5}">
           <p14:sldIdLst>
             <p14:sldId id="272"/>
           </p14:sldIdLst>

</xml_diff>